<commit_message>
Focus report, slides and docs on Project 16 only
</commit_message>
<xml_diff>
--- a/Mini-Meet-Slides.pptx
+++ b/Mini-Meet-Slides.pptx
@@ -122,13 +122,13 @@
   <p:extLst>
     <p:ext uri="{521415D9-36F7-43E2-AB2F-B90AF26B5E84}">
       <p14:sectionLst xmlns:p14="http://schemas.microsoft.com/office/powerpoint/2010/main">
-        <p14:section name="Overview" id="{eca8e7a1-26c1-9bbf-ea5c-f98d16724902}">
+        <p14:section name="Overview" id="{c9145578-7eb5-aca2-7146-a4efd71f3dfa}">
           <p14:sldIdLst>
             <p14:sldId id="256"/>
             <p14:sldId id="257"/>
           </p14:sldIdLst>
         </p14:section>
-        <p14:section name="How it works" id="{6b732626-2858-125a-a6db-e427478d1d26}">
+        <p14:section name="How it works" id="{58f85f73-5287-c610-3972-601f59306a2c}">
           <p14:sldIdLst>
             <p14:sldId id="258"/>
             <p14:sldId id="259"/>
@@ -140,7 +140,7 @@
             <p14:sldId id="265"/>
           </p14:sldIdLst>
         </p14:section>
-        <p14:section name="Evaluation" id="{3101de48-dec6-7af4-febb-d2bdf2f0e2c5}">
+        <p14:section name="Evaluation" id="{d1c6d731-5d28-c35d-6614-acbbdd82aaac}">
           <p14:sldIdLst>
             <p14:sldId id="266"/>
             <p14:sldId id="267"/>
@@ -148,7 +148,7 @@
             <p14:sldId id="269"/>
           </p14:sldIdLst>
         </p14:section>
-        <p14:section name="Wrap-up" id="{59be412e-cb99-cb1a-c96c-d282333e1a10}">
+        <p14:section name="Wrap-up" id="{468c4ef4-ee80-fb33-0578-477c969f049a}">
           <p14:sldIdLst>
             <p14:sldId id="270"/>
             <p14:sldId id="271"/>
@@ -5350,7 +5350,7 @@
           <a:p>
             <a:r>
               <a:rPr lang="en-US" dirty="0"/>
-              <a:t>Mini-Meet is a 2 to 4 person video calling app we built in C from the socket level up. The server only introduces the peers; audio and video then go directly between them over UDP. It covers Project 16 and, as we will show, all deliverables of Project 11 as well.</a:t>
+              <a:t>Mini-Meet is a 2 to 4 person video calling app we built in C from the socket level up. The server only introduces the peers; audio and video then go directly between them over UDP. We measured how the call degrades and adapts under emulated packet loss, jitter and bandwidth limits.</a:t>
             </a:r>
             <a:endParaRPr lang="en-US" dirty="0"/>
           </a:p>
@@ -6054,7 +6054,7 @@
           <a:p>
             <a:r>
               <a:rPr lang="en-US" dirty="0"/>
-              <a:t>Left: the deliverables from the two briefs. Right: the actual client window. The overlay shows the selected network path, the encryption safety code, RTT, loss, jitter and freezes, measured live.</a:t>
+              <a:t>Left: every deliverable and milestone from the project brief, all done. Right: the actual client window. The overlay shows the selected network path, the encryption safety code, RTT, loss, jitter and freezes, measured live.</a:t>
             </a:r>
             <a:endParaRPr lang="en-US" dirty="0"/>
           </a:p>
@@ -7523,7 +7523,7 @@
                   <a:schemeClr val="accent1"/>
                 </a:solidFill>
               </a:rPr>
-              <a:t>COMPUTER NETWORKS · PROJECT 16 · ALSO COVERS PROJECT 11</a:t>
+              <a:t>COMPUTER NETWORKS · PROJECT 16 · VIDEO CONFERENCING APPLICATION</a:t>
             </a:r>
             <a:endParaRPr lang="en-US" sz="1400" dirty="0"/>
           </a:p>
@@ -12317,7 +12317,7 @@
                   <a:schemeClr val="tx1"/>
                 </a:solidFill>
               </a:rPr>
-              <a:t>Every deliverable of both briefs is working</a:t>
+              <a:t>Every deliverable in the brief is working</a:t>
             </a:r>
             <a:endParaRPr lang="en-US" sz="3200" dirty="0"/>
           </a:p>
@@ -12353,7 +12353,7 @@
                   <a:schemeClr val="tx1"/>
                 </a:solidFill>
               </a:rPr>
-              <a:t>Project 16: video conferencing</a:t>
+              <a:t>Deliverables</a:t>
             </a:r>
             <a:endParaRPr lang="en-US" sz="1800" dirty="0"/>
           </a:p>
@@ -12501,7 +12501,7 @@
                   <a:schemeClr val="tx1"/>
                 </a:solidFill>
               </a:rPr>
-              <a:t>Project 11: adaptive streaming</a:t>
+              <a:t>Milestones</a:t>
             </a:r>
             <a:endParaRPr lang="en-US" sz="1800" dirty="0"/>
           </a:p>
@@ -12541,7 +12541,7 @@
                   <a:schemeClr val="tx2"/>
                 </a:solidFill>
               </a:rPr>
-              <a:t>Live or recorded media over UDP</a:t>
+              <a:t>Signalling server and two-party media path</a:t>
             </a:r>
             <a:endParaRPr lang="en-US" sz="1500" dirty="0"/>
           </a:p>
@@ -12559,7 +12559,7 @@
                   <a:schemeClr val="tx2"/>
                 </a:solidFill>
               </a:rPr>
-              <a:t>Own framing layer: sequence numbers + timestamps</a:t>
+              <a:t>NAT traversal and multi-party (mesh) topology</a:t>
             </a:r>
             <a:endParaRPr lang="en-US" sz="1500" dirty="0"/>
           </a:p>
@@ -12577,7 +12577,7 @@
                   <a:schemeClr val="tx2"/>
                 </a:solidFill>
               </a:rPr>
-              <a:t>Jitter buffer with measured playout smoothness</a:t>
+              <a:t>Quality instrumentation and adaptation behaviour</a:t>
             </a:r>
             <a:endParaRPr lang="en-US" sz="1500" dirty="0"/>
           </a:p>
@@ -12595,7 +12595,7 @@
                   <a:schemeClr val="tx2"/>
                 </a:solidFill>
               </a:rPr>
-              <a:t>Bitrate adaptation across changing conditions</a:t>
+              <a:t>Impairment evaluation with tc netem, report</a:t>
             </a:r>
             <a:endParaRPr lang="en-US" sz="1500" dirty="0"/>
           </a:p>
@@ -12631,7 +12631,7 @@
                   <a:schemeClr val="accent1"/>
                 </a:solidFill>
               </a:rPr>
-              <a:t>Beyond the briefs: end-to-end encryption · Windows + Linux · 72 unit-test checks</a:t>
+              <a:t>Also built: end-to-end encryption · adaptive jitter buffer · Windows + Linux · 72 unit-test checks</a:t>
             </a:r>
             <a:endParaRPr lang="en-US" sz="1400" dirty="0"/>
           </a:p>

</xml_diff>

<commit_message>
Slides and report: drop app screenshot (live demo instead), use PC1/PC2/PC3 placeholder names
</commit_message>
<xml_diff>
--- a/Mini-Meet-Slides.pptx
+++ b/Mini-Meet-Slides.pptx
@@ -122,13 +122,13 @@
   <p:extLst>
     <p:ext uri="{521415D9-36F7-43E2-AB2F-B90AF26B5E84}">
       <p14:sectionLst xmlns:p14="http://schemas.microsoft.com/office/powerpoint/2010/main">
-        <p14:section name="Overview" id="{c9145578-7eb5-aca2-7146-a4efd71f3dfa}">
+        <p14:section name="Overview" id="{8a15ab73-b3ed-15d9-1c98-25c128cb21cc}">
           <p14:sldIdLst>
             <p14:sldId id="256"/>
             <p14:sldId id="257"/>
           </p14:sldIdLst>
         </p14:section>
-        <p14:section name="How it works" id="{58f85f73-5287-c610-3972-601f59306a2c}">
+        <p14:section name="How it works" id="{5f9b4db8-0529-6adb-b25b-ef014b77b612}">
           <p14:sldIdLst>
             <p14:sldId id="258"/>
             <p14:sldId id="259"/>
@@ -140,7 +140,7 @@
             <p14:sldId id="265"/>
           </p14:sldIdLst>
         </p14:section>
-        <p14:section name="Evaluation" id="{d1c6d731-5d28-c35d-6614-acbbdd82aaac}">
+        <p14:section name="Evaluation" id="{bdf58721-d13e-4042-bb42-9c247270f4b7}">
           <p14:sldIdLst>
             <p14:sldId id="266"/>
             <p14:sldId id="267"/>
@@ -148,7 +148,7 @@
             <p14:sldId id="269"/>
           </p14:sldIdLst>
         </p14:section>
-        <p14:section name="Wrap-up" id="{468c4ef4-ee80-fb33-0578-477c969f049a}">
+        <p14:section name="Wrap-up" id="{dbc1a88f-bd1a-73ae-4969-938a1df1c1cc}">
           <p14:sldIdLst>
             <p14:sldId id="270"/>
             <p14:sldId id="271"/>
@@ -6054,7 +6054,7 @@
           <a:p>
             <a:r>
               <a:rPr lang="en-US" dirty="0"/>
-              <a:t>Left: every deliverable and milestone from the project brief, all done. Right: the actual client window. The overlay shows the selected network path, the encryption safety code, RTT, loss, jitter and freezes, measured live.</a:t>
+              <a:t>Every deliverable and milestone from the project brief is done. The live demo on our laptops comes at the end.</a:t>
             </a:r>
             <a:endParaRPr lang="en-US" dirty="0"/>
           </a:p>
@@ -7831,7 +7831,7 @@
       </p:sp>
       <p:sp>
         <p:nvSpPr>
-          <p:cNvPr id="3" name="card-152"/>
+          <p:cNvPr id="3" name="card-167"/>
           <p:cNvSpPr/>
           <p:nvPr/>
         </p:nvSpPr>
@@ -7853,7 +7853,7 @@
       </p:sp>
       <p:sp>
         <p:nvSpPr>
-          <p:cNvPr id="4" name="badge-153"/>
+          <p:cNvPr id="4" name="badge-168"/>
           <p:cNvSpPr/>
           <p:nvPr/>
         </p:nvSpPr>
@@ -7873,7 +7873,7 @@
       </p:sp>
       <p:sp>
         <p:nvSpPr>
-          <p:cNvPr id="5" name="badge-text-154"/>
+          <p:cNvPr id="5" name="badge-text-169"/>
           <p:cNvSpPr txBox="1"/>
           <p:nvPr/>
         </p:nvSpPr>
@@ -7909,7 +7909,7 @@
       </p:sp>
       <p:sp>
         <p:nvSpPr>
-          <p:cNvPr id="6" name="text-155"/>
+          <p:cNvPr id="6" name="text-170"/>
           <p:cNvSpPr txBox="1"/>
           <p:nvPr/>
         </p:nvSpPr>
@@ -7945,7 +7945,7 @@
       </p:sp>
       <p:sp>
         <p:nvSpPr>
-          <p:cNvPr id="7" name="text-156"/>
+          <p:cNvPr id="7" name="text-171"/>
           <p:cNvSpPr txBox="1"/>
           <p:nvPr/>
         </p:nvSpPr>
@@ -7981,7 +7981,7 @@
       </p:sp>
       <p:sp>
         <p:nvSpPr>
-          <p:cNvPr id="8" name="arrow-157"/>
+          <p:cNvPr id="8" name="arrow-172"/>
           <p:cNvSpPr/>
           <p:nvPr/>
         </p:nvSpPr>
@@ -8005,7 +8005,7 @@
       </p:sp>
       <p:sp>
         <p:nvSpPr>
-          <p:cNvPr id="9" name="card-158"/>
+          <p:cNvPr id="9" name="card-173"/>
           <p:cNvSpPr/>
           <p:nvPr/>
         </p:nvSpPr>
@@ -8027,7 +8027,7 @@
       </p:sp>
       <p:sp>
         <p:nvSpPr>
-          <p:cNvPr id="10" name="badge-159"/>
+          <p:cNvPr id="10" name="badge-174"/>
           <p:cNvSpPr/>
           <p:nvPr/>
         </p:nvSpPr>
@@ -8047,7 +8047,7 @@
       </p:sp>
       <p:sp>
         <p:nvSpPr>
-          <p:cNvPr id="11" name="badge-text-160"/>
+          <p:cNvPr id="11" name="badge-text-175"/>
           <p:cNvSpPr txBox="1"/>
           <p:nvPr/>
         </p:nvSpPr>
@@ -8083,7 +8083,7 @@
       </p:sp>
       <p:sp>
         <p:nvSpPr>
-          <p:cNvPr id="12" name="text-161"/>
+          <p:cNvPr id="12" name="text-176"/>
           <p:cNvSpPr txBox="1"/>
           <p:nvPr/>
         </p:nvSpPr>
@@ -8119,7 +8119,7 @@
       </p:sp>
       <p:sp>
         <p:nvSpPr>
-          <p:cNvPr id="13" name="text-162"/>
+          <p:cNvPr id="13" name="text-177"/>
           <p:cNvSpPr txBox="1"/>
           <p:nvPr/>
         </p:nvSpPr>
@@ -8155,7 +8155,7 @@
       </p:sp>
       <p:sp>
         <p:nvSpPr>
-          <p:cNvPr id="14" name="arrow-163"/>
+          <p:cNvPr id="14" name="arrow-178"/>
           <p:cNvSpPr/>
           <p:nvPr/>
         </p:nvSpPr>
@@ -8179,7 +8179,7 @@
       </p:sp>
       <p:sp>
         <p:nvSpPr>
-          <p:cNvPr id="15" name="card-164"/>
+          <p:cNvPr id="15" name="card-179"/>
           <p:cNvSpPr/>
           <p:nvPr/>
         </p:nvSpPr>
@@ -8201,7 +8201,7 @@
       </p:sp>
       <p:sp>
         <p:nvSpPr>
-          <p:cNvPr id="16" name="badge-165"/>
+          <p:cNvPr id="16" name="badge-180"/>
           <p:cNvSpPr/>
           <p:nvPr/>
         </p:nvSpPr>
@@ -8221,7 +8221,7 @@
       </p:sp>
       <p:sp>
         <p:nvSpPr>
-          <p:cNvPr id="17" name="badge-text-166"/>
+          <p:cNvPr id="17" name="badge-text-181"/>
           <p:cNvSpPr txBox="1"/>
           <p:nvPr/>
         </p:nvSpPr>
@@ -8257,7 +8257,7 @@
       </p:sp>
       <p:sp>
         <p:nvSpPr>
-          <p:cNvPr id="18" name="text-167"/>
+          <p:cNvPr id="18" name="text-182"/>
           <p:cNvSpPr txBox="1"/>
           <p:nvPr/>
         </p:nvSpPr>
@@ -8293,7 +8293,7 @@
       </p:sp>
       <p:sp>
         <p:nvSpPr>
-          <p:cNvPr id="19" name="text-168"/>
+          <p:cNvPr id="19" name="text-183"/>
           <p:cNvSpPr txBox="1"/>
           <p:nvPr/>
         </p:nvSpPr>
@@ -8329,7 +8329,7 @@
       </p:sp>
       <p:sp>
         <p:nvSpPr>
-          <p:cNvPr id="20" name="card-169"/>
+          <p:cNvPr id="20" name="card-184"/>
           <p:cNvSpPr/>
           <p:nvPr/>
         </p:nvSpPr>
@@ -8351,7 +8351,7 @@
       </p:sp>
       <p:sp>
         <p:nvSpPr>
-          <p:cNvPr id="21" name="text-170"/>
+          <p:cNvPr id="21" name="text-185"/>
           <p:cNvSpPr txBox="1"/>
           <p:nvPr/>
         </p:nvSpPr>
@@ -8387,7 +8387,7 @@
       </p:sp>
       <p:sp>
         <p:nvSpPr>
-          <p:cNvPr id="22" name="text-171"/>
+          <p:cNvPr id="22" name="text-186"/>
           <p:cNvSpPr txBox="1"/>
           <p:nvPr/>
         </p:nvSpPr>
@@ -8423,7 +8423,7 @@
       </p:sp>
       <p:sp>
         <p:nvSpPr>
-          <p:cNvPr id="23" name="card-172"/>
+          <p:cNvPr id="23" name="card-187"/>
           <p:cNvSpPr/>
           <p:nvPr/>
         </p:nvSpPr>
@@ -8445,7 +8445,7 @@
       </p:sp>
       <p:sp>
         <p:nvSpPr>
-          <p:cNvPr id="24" name="text-173"/>
+          <p:cNvPr id="24" name="text-188"/>
           <p:cNvSpPr txBox="1"/>
           <p:nvPr/>
         </p:nvSpPr>
@@ -8481,7 +8481,7 @@
       </p:sp>
       <p:sp>
         <p:nvSpPr>
-          <p:cNvPr id="25" name="text-174"/>
+          <p:cNvPr id="25" name="text-189"/>
           <p:cNvSpPr txBox="1"/>
           <p:nvPr/>
         </p:nvSpPr>
@@ -8625,7 +8625,7 @@
       </p:sp>
       <p:sp>
         <p:nvSpPr>
-          <p:cNvPr id="3" name="card-175"/>
+          <p:cNvPr id="3" name="card-190"/>
           <p:cNvSpPr/>
           <p:nvPr/>
         </p:nvSpPr>
@@ -8647,7 +8647,7 @@
       </p:sp>
       <p:sp>
         <p:nvSpPr>
-          <p:cNvPr id="4" name="text-176"/>
+          <p:cNvPr id="4" name="text-191"/>
           <p:cNvSpPr txBox="1"/>
           <p:nvPr/>
         </p:nvSpPr>
@@ -8683,7 +8683,7 @@
       </p:sp>
       <p:sp>
         <p:nvSpPr>
-          <p:cNvPr id="5" name="text-177"/>
+          <p:cNvPr id="5" name="text-192"/>
           <p:cNvSpPr txBox="1"/>
           <p:nvPr/>
         </p:nvSpPr>
@@ -8719,7 +8719,7 @@
       </p:sp>
       <p:sp>
         <p:nvSpPr>
-          <p:cNvPr id="6" name="card-178"/>
+          <p:cNvPr id="6" name="card-193"/>
           <p:cNvSpPr/>
           <p:nvPr/>
         </p:nvSpPr>
@@ -8741,7 +8741,7 @@
       </p:sp>
       <p:sp>
         <p:nvSpPr>
-          <p:cNvPr id="7" name="text-179"/>
+          <p:cNvPr id="7" name="text-194"/>
           <p:cNvSpPr txBox="1"/>
           <p:nvPr/>
         </p:nvSpPr>
@@ -8777,7 +8777,7 @@
       </p:sp>
       <p:sp>
         <p:nvSpPr>
-          <p:cNvPr id="8" name="text-180"/>
+          <p:cNvPr id="8" name="text-195"/>
           <p:cNvSpPr txBox="1"/>
           <p:nvPr/>
         </p:nvSpPr>
@@ -8813,7 +8813,7 @@
       </p:sp>
       <p:sp>
         <p:nvSpPr>
-          <p:cNvPr id="9" name="veth-181"/>
+          <p:cNvPr id="9" name="veth-196"/>
           <p:cNvSpPr/>
           <p:nvPr/>
         </p:nvSpPr>
@@ -8838,7 +8838,7 @@
       </p:sp>
       <p:sp>
         <p:nvSpPr>
-          <p:cNvPr id="10" name="text-182"/>
+          <p:cNvPr id="10" name="text-197"/>
           <p:cNvSpPr txBox="1"/>
           <p:nvPr/>
         </p:nvSpPr>
@@ -8874,7 +8874,7 @@
       </p:sp>
       <p:sp>
         <p:nvSpPr>
-          <p:cNvPr id="11" name="list-183"/>
+          <p:cNvPr id="11" name="list-198"/>
           <p:cNvSpPr txBox="1"/>
           <p:nvPr/>
         </p:nvSpPr>
@@ -8968,7 +8968,7 @@
       </p:sp>
       <p:graphicFrame>
         <p:nvGraphicFramePr>
-          <p:cNvPr id="12" name="profiles-184"/>
+          <p:cNvPr id="12" name="profiles-199"/>
           <p:cNvGraphicFramePr>
             <a:graphicFrameLocks noGrp="1"/>
           </p:cNvGraphicFramePr>
@@ -9938,7 +9938,7 @@
       </p:sp>
       <p:sp>
         <p:nvSpPr>
-          <p:cNvPr id="3" name="text-185"/>
+          <p:cNvPr id="3" name="text-200"/>
           <p:cNvSpPr txBox="1"/>
           <p:nvPr/>
         </p:nvSpPr>
@@ -9977,7 +9977,7 @@
       </p:sp>
       <p:sp>
         <p:nvSpPr>
-          <p:cNvPr id="4" name="text-186"/>
+          <p:cNvPr id="4" name="text-201"/>
           <p:cNvSpPr txBox="1"/>
           <p:nvPr/>
         </p:nvSpPr>
@@ -10013,7 +10013,7 @@
       </p:sp>
       <p:sp>
         <p:nvSpPr>
-          <p:cNvPr id="5" name="text-187"/>
+          <p:cNvPr id="5" name="text-202"/>
           <p:cNvSpPr txBox="1"/>
           <p:nvPr/>
         </p:nvSpPr>
@@ -10052,7 +10052,7 @@
       </p:sp>
       <p:sp>
         <p:nvSpPr>
-          <p:cNvPr id="6" name="text-188"/>
+          <p:cNvPr id="6" name="text-203"/>
           <p:cNvSpPr txBox="1"/>
           <p:nvPr/>
         </p:nvSpPr>
@@ -10088,7 +10088,7 @@
       </p:sp>
       <p:sp>
         <p:nvSpPr>
-          <p:cNvPr id="7" name="text-189"/>
+          <p:cNvPr id="7" name="text-204"/>
           <p:cNvSpPr txBox="1"/>
           <p:nvPr/>
         </p:nvSpPr>
@@ -10127,7 +10127,7 @@
       </p:sp>
       <p:sp>
         <p:nvSpPr>
-          <p:cNvPr id="8" name="text-190"/>
+          <p:cNvPr id="8" name="text-205"/>
           <p:cNvSpPr txBox="1"/>
           <p:nvPr/>
         </p:nvSpPr>
@@ -10163,7 +10163,7 @@
       </p:sp>
       <p:graphicFrame>
         <p:nvGraphicFramePr>
-          <p:cNvPr id="9" name="conceal-chart-191" descr=""/>
+          <p:cNvPr id="9" name="conceal-chart-206" descr=""/>
           <p:cNvGraphicFramePr/>
           <p:nvPr/>
         </p:nvGraphicFramePr>
@@ -10287,7 +10287,7 @@
       </p:sp>
       <p:graphicFrame>
         <p:nvGraphicFramePr>
-          <p:cNvPr id="3" name="sched-kbps-192" descr=""/>
+          <p:cNvPr id="3" name="sched-kbps-207" descr=""/>
           <p:cNvGraphicFramePr/>
           <p:nvPr/>
         </p:nvGraphicFramePr>
@@ -10303,7 +10303,7 @@
       </p:graphicFrame>
       <p:graphicFrame>
         <p:nvGraphicFramePr>
-          <p:cNvPr id="4" name="sched-rtt-193" descr=""/>
+          <p:cNvPr id="4" name="sched-rtt-208" descr=""/>
           <p:cNvGraphicFramePr/>
           <p:nvPr/>
         </p:nvGraphicFramePr>
@@ -10427,7 +10427,7 @@
       </p:sp>
       <p:sp>
         <p:nvSpPr>
-          <p:cNvPr id="3" name="card-194"/>
+          <p:cNvPr id="3" name="card-209"/>
           <p:cNvSpPr/>
           <p:nvPr/>
         </p:nvSpPr>
@@ -10449,7 +10449,7 @@
       </p:sp>
       <p:sp>
         <p:nvSpPr>
-          <p:cNvPr id="4" name="text-195"/>
+          <p:cNvPr id="4" name="text-210"/>
           <p:cNvSpPr txBox="1"/>
           <p:nvPr/>
         </p:nvSpPr>
@@ -10488,7 +10488,7 @@
       </p:sp>
       <p:sp>
         <p:nvSpPr>
-          <p:cNvPr id="5" name="text-196"/>
+          <p:cNvPr id="5" name="text-211"/>
           <p:cNvSpPr txBox="1"/>
           <p:nvPr/>
         </p:nvSpPr>
@@ -10524,7 +10524,7 @@
       </p:sp>
       <p:sp>
         <p:nvSpPr>
-          <p:cNvPr id="6" name="card-197"/>
+          <p:cNvPr id="6" name="card-212"/>
           <p:cNvSpPr/>
           <p:nvPr/>
         </p:nvSpPr>
@@ -10546,7 +10546,7 @@
       </p:sp>
       <p:sp>
         <p:nvSpPr>
-          <p:cNvPr id="7" name="text-198"/>
+          <p:cNvPr id="7" name="text-213"/>
           <p:cNvSpPr txBox="1"/>
           <p:nvPr/>
         </p:nvSpPr>
@@ -10585,7 +10585,7 @@
       </p:sp>
       <p:sp>
         <p:nvSpPr>
-          <p:cNvPr id="8" name="text-199"/>
+          <p:cNvPr id="8" name="text-214"/>
           <p:cNvSpPr txBox="1"/>
           <p:nvPr/>
         </p:nvSpPr>
@@ -10621,7 +10621,7 @@
       </p:sp>
       <p:sp>
         <p:nvSpPr>
-          <p:cNvPr id="9" name="card-200"/>
+          <p:cNvPr id="9" name="card-215"/>
           <p:cNvSpPr/>
           <p:nvPr/>
         </p:nvSpPr>
@@ -10643,7 +10643,7 @@
       </p:sp>
       <p:sp>
         <p:nvSpPr>
-          <p:cNvPr id="10" name="text-201"/>
+          <p:cNvPr id="10" name="text-216"/>
           <p:cNvSpPr txBox="1"/>
           <p:nvPr/>
         </p:nvSpPr>
@@ -10682,7 +10682,7 @@
       </p:sp>
       <p:sp>
         <p:nvSpPr>
-          <p:cNvPr id="11" name="text-202"/>
+          <p:cNvPr id="11" name="text-217"/>
           <p:cNvSpPr txBox="1"/>
           <p:nvPr/>
         </p:nvSpPr>
@@ -10718,7 +10718,7 @@
       </p:sp>
       <p:sp>
         <p:nvSpPr>
-          <p:cNvPr id="12" name="card-203"/>
+          <p:cNvPr id="12" name="card-218"/>
           <p:cNvSpPr/>
           <p:nvPr/>
         </p:nvSpPr>
@@ -10740,7 +10740,7 @@
       </p:sp>
       <p:sp>
         <p:nvSpPr>
-          <p:cNvPr id="13" name="text-204"/>
+          <p:cNvPr id="13" name="text-219"/>
           <p:cNvSpPr txBox="1"/>
           <p:nvPr/>
         </p:nvSpPr>
@@ -10779,7 +10779,7 @@
       </p:sp>
       <p:sp>
         <p:nvSpPr>
-          <p:cNvPr id="14" name="text-205"/>
+          <p:cNvPr id="14" name="text-220"/>
           <p:cNvSpPr txBox="1"/>
           <p:nvPr/>
         </p:nvSpPr>
@@ -10923,7 +10923,7 @@
       </p:sp>
       <p:sp>
         <p:nvSpPr>
-          <p:cNvPr id="3" name="text-206"/>
+          <p:cNvPr id="3" name="text-221"/>
           <p:cNvSpPr txBox="1"/>
           <p:nvPr/>
         </p:nvSpPr>
@@ -10959,7 +10959,7 @@
       </p:sp>
       <p:sp>
         <p:nvSpPr>
-          <p:cNvPr id="4" name="text-207"/>
+          <p:cNvPr id="4" name="text-222"/>
           <p:cNvSpPr txBox="1"/>
           <p:nvPr/>
         </p:nvSpPr>
@@ -10995,7 +10995,7 @@
       </p:sp>
       <p:sp>
         <p:nvSpPr>
-          <p:cNvPr id="5" name="card-208"/>
+          <p:cNvPr id="5" name="card-223"/>
           <p:cNvSpPr/>
           <p:nvPr/>
         </p:nvSpPr>
@@ -11017,7 +11017,7 @@
       </p:sp>
       <p:sp>
         <p:nvSpPr>
-          <p:cNvPr id="6" name="text-209"/>
+          <p:cNvPr id="6" name="text-224"/>
           <p:cNvSpPr txBox="1"/>
           <p:nvPr/>
         </p:nvSpPr>
@@ -11053,7 +11053,7 @@
       </p:sp>
       <p:sp>
         <p:nvSpPr>
-          <p:cNvPr id="7" name="arrow-210"/>
+          <p:cNvPr id="7" name="arrow-225"/>
           <p:cNvSpPr/>
           <p:nvPr/>
         </p:nvSpPr>
@@ -11077,7 +11077,7 @@
       </p:sp>
       <p:sp>
         <p:nvSpPr>
-          <p:cNvPr id="8" name="card-211"/>
+          <p:cNvPr id="8" name="card-226"/>
           <p:cNvSpPr/>
           <p:nvPr/>
         </p:nvSpPr>
@@ -11099,7 +11099,7 @@
       </p:sp>
       <p:sp>
         <p:nvSpPr>
-          <p:cNvPr id="9" name="text-212"/>
+          <p:cNvPr id="9" name="text-227"/>
           <p:cNvSpPr txBox="1"/>
           <p:nvPr/>
         </p:nvSpPr>
@@ -11135,7 +11135,7 @@
       </p:sp>
       <p:sp>
         <p:nvSpPr>
-          <p:cNvPr id="10" name="card-213"/>
+          <p:cNvPr id="10" name="card-228"/>
           <p:cNvSpPr/>
           <p:nvPr/>
         </p:nvSpPr>
@@ -11157,7 +11157,7 @@
       </p:sp>
       <p:sp>
         <p:nvSpPr>
-          <p:cNvPr id="11" name="text-214"/>
+          <p:cNvPr id="11" name="text-229"/>
           <p:cNvSpPr txBox="1"/>
           <p:nvPr/>
         </p:nvSpPr>
@@ -11193,7 +11193,7 @@
       </p:sp>
       <p:sp>
         <p:nvSpPr>
-          <p:cNvPr id="12" name="arrow-215"/>
+          <p:cNvPr id="12" name="arrow-230"/>
           <p:cNvSpPr/>
           <p:nvPr/>
         </p:nvSpPr>
@@ -11217,7 +11217,7 @@
       </p:sp>
       <p:sp>
         <p:nvSpPr>
-          <p:cNvPr id="13" name="card-216"/>
+          <p:cNvPr id="13" name="card-231"/>
           <p:cNvSpPr/>
           <p:nvPr/>
         </p:nvSpPr>
@@ -11239,7 +11239,7 @@
       </p:sp>
       <p:sp>
         <p:nvSpPr>
-          <p:cNvPr id="14" name="text-217"/>
+          <p:cNvPr id="14" name="text-232"/>
           <p:cNvSpPr txBox="1"/>
           <p:nvPr/>
         </p:nvSpPr>
@@ -11275,7 +11275,7 @@
       </p:sp>
       <p:sp>
         <p:nvSpPr>
-          <p:cNvPr id="15" name="card-218"/>
+          <p:cNvPr id="15" name="card-233"/>
           <p:cNvSpPr/>
           <p:nvPr/>
         </p:nvSpPr>
@@ -11297,7 +11297,7 @@
       </p:sp>
       <p:sp>
         <p:nvSpPr>
-          <p:cNvPr id="16" name="text-219"/>
+          <p:cNvPr id="16" name="text-234"/>
           <p:cNvSpPr txBox="1"/>
           <p:nvPr/>
         </p:nvSpPr>
@@ -11333,7 +11333,7 @@
       </p:sp>
       <p:sp>
         <p:nvSpPr>
-          <p:cNvPr id="17" name="arrow-220"/>
+          <p:cNvPr id="17" name="arrow-235"/>
           <p:cNvSpPr/>
           <p:nvPr/>
         </p:nvSpPr>
@@ -11357,7 +11357,7 @@
       </p:sp>
       <p:sp>
         <p:nvSpPr>
-          <p:cNvPr id="18" name="card-221"/>
+          <p:cNvPr id="18" name="card-236"/>
           <p:cNvSpPr/>
           <p:nvPr/>
         </p:nvSpPr>
@@ -11379,7 +11379,7 @@
       </p:sp>
       <p:sp>
         <p:nvSpPr>
-          <p:cNvPr id="19" name="text-222"/>
+          <p:cNvPr id="19" name="text-237"/>
           <p:cNvSpPr txBox="1"/>
           <p:nvPr/>
         </p:nvSpPr>
@@ -11415,7 +11415,7 @@
       </p:sp>
       <p:sp>
         <p:nvSpPr>
-          <p:cNvPr id="20" name="card-223"/>
+          <p:cNvPr id="20" name="card-238"/>
           <p:cNvSpPr/>
           <p:nvPr/>
         </p:nvSpPr>
@@ -11437,7 +11437,7 @@
       </p:sp>
       <p:sp>
         <p:nvSpPr>
-          <p:cNvPr id="21" name="text-224"/>
+          <p:cNvPr id="21" name="text-239"/>
           <p:cNvSpPr txBox="1"/>
           <p:nvPr/>
         </p:nvSpPr>
@@ -11473,7 +11473,7 @@
       </p:sp>
       <p:sp>
         <p:nvSpPr>
-          <p:cNvPr id="22" name="arrow-225"/>
+          <p:cNvPr id="22" name="arrow-240"/>
           <p:cNvSpPr/>
           <p:nvPr/>
         </p:nvSpPr>
@@ -11497,7 +11497,7 @@
       </p:sp>
       <p:sp>
         <p:nvSpPr>
-          <p:cNvPr id="23" name="card-226"/>
+          <p:cNvPr id="23" name="card-241"/>
           <p:cNvSpPr/>
           <p:nvPr/>
         </p:nvSpPr>
@@ -11519,7 +11519,7 @@
       </p:sp>
       <p:sp>
         <p:nvSpPr>
-          <p:cNvPr id="24" name="text-227"/>
+          <p:cNvPr id="24" name="text-242"/>
           <p:cNvSpPr txBox="1"/>
           <p:nvPr/>
         </p:nvSpPr>
@@ -11555,7 +11555,7 @@
       </p:sp>
       <p:sp>
         <p:nvSpPr>
-          <p:cNvPr id="25" name="card-228"/>
+          <p:cNvPr id="25" name="card-243"/>
           <p:cNvSpPr/>
           <p:nvPr/>
         </p:nvSpPr>
@@ -11577,7 +11577,7 @@
       </p:sp>
       <p:sp>
         <p:nvSpPr>
-          <p:cNvPr id="26" name="text-229"/>
+          <p:cNvPr id="26" name="text-244"/>
           <p:cNvSpPr txBox="1"/>
           <p:nvPr/>
         </p:nvSpPr>
@@ -11613,7 +11613,7 @@
       </p:sp>
       <p:sp>
         <p:nvSpPr>
-          <p:cNvPr id="27" name="arrow-230"/>
+          <p:cNvPr id="27" name="arrow-245"/>
           <p:cNvSpPr/>
           <p:nvPr/>
         </p:nvSpPr>
@@ -11637,7 +11637,7 @@
       </p:sp>
       <p:sp>
         <p:nvSpPr>
-          <p:cNvPr id="28" name="card-231"/>
+          <p:cNvPr id="28" name="card-246"/>
           <p:cNvSpPr/>
           <p:nvPr/>
         </p:nvSpPr>
@@ -11659,7 +11659,7 @@
       </p:sp>
       <p:sp>
         <p:nvSpPr>
-          <p:cNvPr id="29" name="text-232"/>
+          <p:cNvPr id="29" name="text-247"/>
           <p:cNvSpPr txBox="1"/>
           <p:nvPr/>
         </p:nvSpPr>
@@ -11803,7 +11803,7 @@
       </p:sp>
       <p:sp>
         <p:nvSpPr>
-          <p:cNvPr id="3" name="badge-233"/>
+          <p:cNvPr id="3" name="badge-248"/>
           <p:cNvSpPr/>
           <p:nvPr/>
         </p:nvSpPr>
@@ -11823,7 +11823,7 @@
       </p:sp>
       <p:sp>
         <p:nvSpPr>
-          <p:cNvPr id="4" name="badge-text-234"/>
+          <p:cNvPr id="4" name="badge-text-249"/>
           <p:cNvSpPr txBox="1"/>
           <p:nvPr/>
         </p:nvSpPr>
@@ -11859,7 +11859,7 @@
       </p:sp>
       <p:sp>
         <p:nvSpPr>
-          <p:cNvPr id="5" name="text-235"/>
+          <p:cNvPr id="5" name="text-250"/>
           <p:cNvSpPr txBox="1"/>
           <p:nvPr/>
         </p:nvSpPr>
@@ -11895,7 +11895,7 @@
       </p:sp>
       <p:sp>
         <p:nvSpPr>
-          <p:cNvPr id="6" name="text-236"/>
+          <p:cNvPr id="6" name="text-251"/>
           <p:cNvSpPr txBox="1"/>
           <p:nvPr/>
         </p:nvSpPr>
@@ -11931,7 +11931,7 @@
       </p:sp>
       <p:sp>
         <p:nvSpPr>
-          <p:cNvPr id="7" name="badge-237"/>
+          <p:cNvPr id="7" name="badge-252"/>
           <p:cNvSpPr/>
           <p:nvPr/>
         </p:nvSpPr>
@@ -11951,7 +11951,7 @@
       </p:sp>
       <p:sp>
         <p:nvSpPr>
-          <p:cNvPr id="8" name="badge-text-238"/>
+          <p:cNvPr id="8" name="badge-text-253"/>
           <p:cNvSpPr txBox="1"/>
           <p:nvPr/>
         </p:nvSpPr>
@@ -11987,7 +11987,7 @@
       </p:sp>
       <p:sp>
         <p:nvSpPr>
-          <p:cNvPr id="9" name="text-239"/>
+          <p:cNvPr id="9" name="text-254"/>
           <p:cNvSpPr txBox="1"/>
           <p:nvPr/>
         </p:nvSpPr>
@@ -12023,7 +12023,7 @@
       </p:sp>
       <p:sp>
         <p:nvSpPr>
-          <p:cNvPr id="10" name="text-240"/>
+          <p:cNvPr id="10" name="text-255"/>
           <p:cNvSpPr txBox="1"/>
           <p:nvPr/>
         </p:nvSpPr>
@@ -12059,7 +12059,7 @@
       </p:sp>
       <p:sp>
         <p:nvSpPr>
-          <p:cNvPr id="11" name="badge-241"/>
+          <p:cNvPr id="11" name="badge-256"/>
           <p:cNvSpPr/>
           <p:nvPr/>
         </p:nvSpPr>
@@ -12079,7 +12079,7 @@
       </p:sp>
       <p:sp>
         <p:nvSpPr>
-          <p:cNvPr id="12" name="badge-text-242"/>
+          <p:cNvPr id="12" name="badge-text-257"/>
           <p:cNvSpPr txBox="1"/>
           <p:nvPr/>
         </p:nvSpPr>
@@ -12115,7 +12115,7 @@
       </p:sp>
       <p:sp>
         <p:nvSpPr>
-          <p:cNvPr id="13" name="text-243"/>
+          <p:cNvPr id="13" name="text-258"/>
           <p:cNvSpPr txBox="1"/>
           <p:nvPr/>
         </p:nvSpPr>
@@ -12151,7 +12151,7 @@
       </p:sp>
       <p:sp>
         <p:nvSpPr>
-          <p:cNvPr id="14" name="text-244"/>
+          <p:cNvPr id="14" name="text-259"/>
           <p:cNvSpPr txBox="1"/>
           <p:nvPr/>
         </p:nvSpPr>
@@ -12187,7 +12187,7 @@
       </p:sp>
       <p:sp>
         <p:nvSpPr>
-          <p:cNvPr id="15" name="demo-245"/>
+          <p:cNvPr id="15" name="demo-260"/>
           <p:cNvSpPr/>
           <p:nvPr/>
         </p:nvSpPr>
@@ -12209,7 +12209,7 @@
       </p:sp>
       <p:sp>
         <p:nvSpPr>
-          <p:cNvPr id="16" name="text-246"/>
+          <p:cNvPr id="16" name="text-261"/>
           <p:cNvSpPr txBox="1"/>
           <p:nvPr/>
         </p:nvSpPr>
@@ -12254,7 +12254,7 @@
                 <a:ea typeface="Consolas" pitchFamily="34" charset="-122"/>
                 <a:cs typeface="Consolas" pitchFamily="34" charset="-120"/>
               </a:rPr>
-              <a:t>mm-server   ·   mm --server 127.0.0.1 --room demo --name A   ·   mm ... --name B --test</a:t>
+              <a:t>mm-server   ·   mm --server 127.0.0.1 --room demo --name PC1   ·   mm ... --name PC2 --test</a:t>
             </a:r>
             <a:endParaRPr lang="en-US" sz="1600" dirty="0"/>
           </a:p>
@@ -12325,14 +12325,36 @@
       </p:sp>
       <p:sp>
         <p:nvSpPr>
-          <p:cNvPr id="3" name="text-11"/>
+          <p:cNvPr id="3" name="card-11"/>
+          <p:cNvSpPr/>
+          <p:nvPr/>
+        </p:nvSpPr>
+        <p:spPr>
+          <a:xfrm>
+            <a:off x="548640" y="1371600"/>
+            <a:ext cx="5486400" cy="4343400"/>
+          </a:xfrm>
+          <a:prstGeom prst="roundRect">
+            <a:avLst>
+              <a:gd name="adj" fmla="val 2526"/>
+            </a:avLst>
+          </a:prstGeom>
+          <a:solidFill>
+            <a:schemeClr val="bg2"/>
+          </a:solidFill>
+          <a:ln/>
+        </p:spPr>
+      </p:sp>
+      <p:sp>
+        <p:nvSpPr>
+          <p:cNvPr id="4" name="text-12"/>
           <p:cNvSpPr txBox="1"/>
           <p:nvPr/>
         </p:nvSpPr>
         <p:spPr>
           <a:xfrm>
-            <a:off x="548640" y="1325880"/>
-            <a:ext cx="5212080" cy="365760"/>
+            <a:off x="822960" y="1554480"/>
+            <a:ext cx="4937760" cy="411480"/>
           </a:xfrm>
           <a:prstGeom prst="rect">
             <a:avLst/>
@@ -12348,126 +12370,14 @@
               <a:buNone/>
             </a:pPr>
             <a:r>
-              <a:rPr lang="en-US" sz="1800" b="1" dirty="0">
+              <a:rPr lang="en-US" sz="1900" b="1" dirty="0">
                 <a:solidFill>
                   <a:schemeClr val="tx1"/>
                 </a:solidFill>
               </a:rPr>
               <a:t>Deliverables</a:t>
             </a:r>
-            <a:endParaRPr lang="en-US" sz="1800" dirty="0"/>
-          </a:p>
-        </p:txBody>
-      </p:sp>
-      <p:sp>
-        <p:nvSpPr>
-          <p:cNvPr id="4" name="list-12"/>
-          <p:cNvSpPr txBox="1"/>
-          <p:nvPr/>
-        </p:nvSpPr>
-        <p:spPr>
-          <a:xfrm>
-            <a:off x="548640" y="1737360"/>
-            <a:ext cx="5394960" cy="1920240"/>
-          </a:xfrm>
-          <a:prstGeom prst="rect">
-            <a:avLst/>
-          </a:prstGeom>
-          <a:noFill/>
-          <a:ln/>
-        </p:spPr>
-        <p:txBody>
-          <a:bodyPr wrap="square" lIns="0" tIns="0" rIns="0" bIns="0" rtlCol="0" anchor="t"/>
-          <a:lstStyle/>
-          <a:p>
-            <a:pPr marL="203200" indent="-203200">
-              <a:spcAft>
-                <a:spcPts val="600"/>
-              </a:spcAft>
-              <a:buSzPct val="100000"/>
-              <a:buChar char="•"/>
-            </a:pPr>
-            <a:r>
-              <a:rPr lang="en-US" sz="1500" dirty="0">
-                <a:solidFill>
-                  <a:schemeClr val="tx2"/>
-                </a:solidFill>
-              </a:rPr>
-              <a:t>2–4 person audio + video call (VP8 + Opus)</a:t>
-            </a:r>
-            <a:endParaRPr lang="en-US" sz="1500" dirty="0"/>
-          </a:p>
-          <a:p>
-            <a:pPr marL="203200" indent="-203200">
-              <a:spcAft>
-                <a:spcPts val="600"/>
-              </a:spcAft>
-              <a:buSzPct val="100000"/>
-              <a:buChar char="•"/>
-            </a:pPr>
-            <a:r>
-              <a:rPr lang="en-US" sz="1500" dirty="0">
-                <a:solidFill>
-                  <a:schemeClr val="tx2"/>
-                </a:solidFill>
-              </a:rPr>
-              <a:t>Custom signalling server and documented protocol</a:t>
-            </a:r>
-            <a:endParaRPr lang="en-US" sz="1500" dirty="0"/>
-          </a:p>
-          <a:p>
-            <a:pPr marL="203200" indent="-203200">
-              <a:spcAft>
-                <a:spcPts val="600"/>
-              </a:spcAft>
-              <a:buSzPct val="100000"/>
-              <a:buChar char="•"/>
-            </a:pPr>
-            <a:r>
-              <a:rPr lang="en-US" sz="1500" dirty="0">
-                <a:solidFill>
-                  <a:schemeClr val="tx2"/>
-                </a:solidFill>
-              </a:rPr>
-              <a:t>STUN NAT traversal across separate networks</a:t>
-            </a:r>
-            <a:endParaRPr lang="en-US" sz="1500" dirty="0"/>
-          </a:p>
-          <a:p>
-            <a:pPr marL="203200" indent="-203200">
-              <a:spcAft>
-                <a:spcPts val="600"/>
-              </a:spcAft>
-              <a:buSzPct val="100000"/>
-              <a:buChar char="•"/>
-            </a:pPr>
-            <a:r>
-              <a:rPr lang="en-US" sz="1500" dirty="0">
-                <a:solidFill>
-                  <a:schemeClr val="tx2"/>
-                </a:solidFill>
-              </a:rPr>
-              <a:t>Quality measured under loss, jitter, bandwidth caps</a:t>
-            </a:r>
-            <a:endParaRPr lang="en-US" sz="1500" dirty="0"/>
-          </a:p>
-          <a:p>
-            <a:pPr marL="203200" indent="-203200">
-              <a:spcAft>
-                <a:spcPts val="600"/>
-              </a:spcAft>
-              <a:buSzPct val="100000"/>
-              <a:buChar char="•"/>
-            </a:pPr>
-            <a:r>
-              <a:rPr lang="en-US" sz="1500" dirty="0">
-                <a:solidFill>
-                  <a:schemeClr val="tx2"/>
-                </a:solidFill>
-              </a:rPr>
-              <a:t>Architecture: media path vs signalling path</a:t>
-            </a:r>
-            <a:endParaRPr lang="en-US" sz="1500" dirty="0"/>
+            <a:endParaRPr lang="en-US" sz="1900" dirty="0"/>
           </a:p>
         </p:txBody>
       </p:sp>
@@ -12479,8 +12389,8 @@
         </p:nvSpPr>
         <p:spPr>
           <a:xfrm>
-            <a:off x="548640" y="3703320"/>
-            <a:ext cx="5212080" cy="365760"/>
+            <a:off x="822960" y="2103120"/>
+            <a:ext cx="4983480" cy="594360"/>
           </a:xfrm>
           <a:prstGeom prst="rect">
             <a:avLst/>
@@ -12496,27 +12406,38 @@
               <a:buNone/>
             </a:pPr>
             <a:r>
-              <a:rPr lang="en-US" sz="1800" b="1" dirty="0">
+              <a:rPr lang="en-US" sz="1500" b="1" dirty="0">
                 <a:solidFill>
                   <a:schemeClr val="tx1"/>
                 </a:solidFill>
               </a:rPr>
-              <a:t>Milestones</a:t>
-            </a:r>
-            <a:endParaRPr lang="en-US" sz="1800" dirty="0"/>
-          </a:p>
-        </p:txBody>
-      </p:sp>
-      <p:sp>
-        <p:nvSpPr>
-          <p:cNvPr id="6" name="list-14"/>
+              <a:t>Multi-party call: </a:t>
+            </a:r>
+            <a:pPr indent="0" marL="0">
+              <a:buNone/>
+            </a:pPr>
+            <a:r>
+              <a:rPr lang="en-US" sz="1500" dirty="0">
+                <a:solidFill>
+                  <a:schemeClr val="tx2"/>
+                </a:solidFill>
+              </a:rPr>
+              <a:t>2–4 people, audio and video</a:t>
+            </a:r>
+            <a:endParaRPr lang="en-US" sz="1500" dirty="0"/>
+          </a:p>
+        </p:txBody>
+      </p:sp>
+      <p:sp>
+        <p:nvSpPr>
+          <p:cNvPr id="6" name="text-14"/>
           <p:cNvSpPr txBox="1"/>
           <p:nvPr/>
         </p:nvSpPr>
         <p:spPr>
           <a:xfrm>
-            <a:off x="548640" y="4114800"/>
-            <a:ext cx="5394960" cy="1554480"/>
+            <a:off x="822960" y="2788920"/>
+            <a:ext cx="4983480" cy="594360"/>
           </a:xfrm>
           <a:prstGeom prst="rect">
             <a:avLst/>
@@ -12528,12 +12449,19 @@
           <a:bodyPr wrap="square" lIns="0" tIns="0" rIns="0" bIns="0" rtlCol="0" anchor="t"/>
           <a:lstStyle/>
           <a:p>
-            <a:pPr marL="203200" indent="-203200">
-              <a:spcAft>
-                <a:spcPts val="600"/>
-              </a:spcAft>
-              <a:buSzPct val="100000"/>
-              <a:buChar char="•"/>
+            <a:pPr indent="0" marL="0">
+              <a:buNone/>
+            </a:pPr>
+            <a:r>
+              <a:rPr lang="en-US" sz="1500" b="1" dirty="0">
+                <a:solidFill>
+                  <a:schemeClr val="tx1"/>
+                </a:solidFill>
+              </a:rPr>
+              <a:t>Signalling: </a:t>
+            </a:r>
+            <a:pPr indent="0" marL="0">
+              <a:buNone/>
             </a:pPr>
             <a:r>
               <a:rPr lang="en-US" sz="1500" dirty="0">
@@ -12541,61 +12469,7 @@
                   <a:schemeClr val="tx2"/>
                 </a:solidFill>
               </a:rPr>
-              <a:t>Signalling server and two-party media path</a:t>
-            </a:r>
-            <a:endParaRPr lang="en-US" sz="1500" dirty="0"/>
-          </a:p>
-          <a:p>
-            <a:pPr marL="203200" indent="-203200">
-              <a:spcAft>
-                <a:spcPts val="600"/>
-              </a:spcAft>
-              <a:buSzPct val="100000"/>
-              <a:buChar char="•"/>
-            </a:pPr>
-            <a:r>
-              <a:rPr lang="en-US" sz="1500" dirty="0">
-                <a:solidFill>
-                  <a:schemeClr val="tx2"/>
-                </a:solidFill>
-              </a:rPr>
-              <a:t>NAT traversal and multi-party (mesh) topology</a:t>
-            </a:r>
-            <a:endParaRPr lang="en-US" sz="1500" dirty="0"/>
-          </a:p>
-          <a:p>
-            <a:pPr marL="203200" indent="-203200">
-              <a:spcAft>
-                <a:spcPts val="600"/>
-              </a:spcAft>
-              <a:buSzPct val="100000"/>
-              <a:buChar char="•"/>
-            </a:pPr>
-            <a:r>
-              <a:rPr lang="en-US" sz="1500" dirty="0">
-                <a:solidFill>
-                  <a:schemeClr val="tx2"/>
-                </a:solidFill>
-              </a:rPr>
-              <a:t>Quality instrumentation and adaptation behaviour</a:t>
-            </a:r>
-            <a:endParaRPr lang="en-US" sz="1500" dirty="0"/>
-          </a:p>
-          <a:p>
-            <a:pPr marL="203200" indent="-203200">
-              <a:spcAft>
-                <a:spcPts val="600"/>
-              </a:spcAft>
-              <a:buSzPct val="100000"/>
-              <a:buChar char="•"/>
-            </a:pPr>
-            <a:r>
-              <a:rPr lang="en-US" sz="1500" dirty="0">
-                <a:solidFill>
-                  <a:schemeClr val="tx2"/>
-                </a:solidFill>
-              </a:rPr>
-              <a:t>Impairment evaluation with tc netem, report</a:t>
+              <a:t>our own server and a documented text protocol</a:t>
             </a:r>
             <a:endParaRPr lang="en-US" sz="1500" dirty="0"/>
           </a:p>
@@ -12609,8 +12483,8 @@
         </p:nvSpPr>
         <p:spPr>
           <a:xfrm>
-            <a:off x="548640" y="5806440"/>
-            <a:ext cx="5669280" cy="320040"/>
+            <a:off x="822960" y="3474720"/>
+            <a:ext cx="4983480" cy="594360"/>
           </a:xfrm>
           <a:prstGeom prst="rect">
             <a:avLst/>
@@ -12626,41 +12500,75 @@
               <a:buNone/>
             </a:pPr>
             <a:r>
-              <a:rPr lang="en-US" sz="1400" i="1" dirty="0">
-                <a:solidFill>
-                  <a:schemeClr val="accent1"/>
-                </a:solidFill>
-              </a:rPr>
-              <a:t>Also built: end-to-end encryption · adaptive jitter buffer · Windows + Linux · 72 unit-test checks</a:t>
-            </a:r>
-            <a:endParaRPr lang="en-US" sz="1400" dirty="0"/>
-          </a:p>
-        </p:txBody>
-      </p:sp>
-      <p:pic>
-        <p:nvPicPr>
-          <p:cNvPr id="8" name="screenshot-16" descr="/mnt/e/MiniMeet/docs/img/app-window.png">    </p:cNvPr>
-          <p:cNvPicPr>
-            <a:picLocks noChangeAspect="1"/>
-          </p:cNvPicPr>
-          <p:nvPr/>
-        </p:nvPicPr>
-        <p:blipFill>
-          <a:blip r:embed="rId1"/>
-          <a:stretch>
-            <a:fillRect/>
-          </a:stretch>
-        </p:blipFill>
-        <p:spPr>
-          <a:xfrm>
-            <a:off x="6263640" y="1463040"/>
-            <a:ext cx="5349240" cy="3145536"/>
-          </a:xfrm>
-          <a:prstGeom prst="rect">
-            <a:avLst/>
-          </a:prstGeom>
-        </p:spPr>
-      </p:pic>
+              <a:rPr lang="en-US" sz="1500" b="1" dirty="0">
+                <a:solidFill>
+                  <a:schemeClr val="tx1"/>
+                </a:solidFill>
+              </a:rPr>
+              <a:t>NAT traversal: </a:t>
+            </a:r>
+            <a:pPr indent="0" marL="0">
+              <a:buNone/>
+            </a:pPr>
+            <a:r>
+              <a:rPr lang="en-US" sz="1500" dirty="0">
+                <a:solidFill>
+                  <a:schemeClr val="tx2"/>
+                </a:solidFill>
+              </a:rPr>
+              <a:t>STUN, tested across two networks</a:t>
+            </a:r>
+            <a:endParaRPr lang="en-US" sz="1500" dirty="0"/>
+          </a:p>
+        </p:txBody>
+      </p:sp>
+      <p:sp>
+        <p:nvSpPr>
+          <p:cNvPr id="8" name="text-16"/>
+          <p:cNvSpPr txBox="1"/>
+          <p:nvPr/>
+        </p:nvSpPr>
+        <p:spPr>
+          <a:xfrm>
+            <a:off x="822960" y="4160520"/>
+            <a:ext cx="4983480" cy="594360"/>
+          </a:xfrm>
+          <a:prstGeom prst="rect">
+            <a:avLst/>
+          </a:prstGeom>
+          <a:noFill/>
+          <a:ln/>
+        </p:spPr>
+        <p:txBody>
+          <a:bodyPr wrap="square" lIns="0" tIns="0" rIns="0" bIns="0" rtlCol="0" anchor="t"/>
+          <a:lstStyle/>
+          <a:p>
+            <a:pPr indent="0" marL="0">
+              <a:buNone/>
+            </a:pPr>
+            <a:r>
+              <a:rPr lang="en-US" sz="1500" b="1" dirty="0">
+                <a:solidFill>
+                  <a:schemeClr val="tx1"/>
+                </a:solidFill>
+              </a:rPr>
+              <a:t>Call quality: </a:t>
+            </a:r>
+            <a:pPr indent="0" marL="0">
+              <a:buNone/>
+            </a:pPr>
+            <a:r>
+              <a:rPr lang="en-US" sz="1500" dirty="0">
+                <a:solidFill>
+                  <a:schemeClr val="tx2"/>
+                </a:solidFill>
+              </a:rPr>
+              <a:t>measured under loss, jitter and bandwidth limits</a:t>
+            </a:r>
+            <a:endParaRPr lang="en-US" sz="1500" dirty="0"/>
+          </a:p>
+        </p:txBody>
+      </p:sp>
       <p:sp>
         <p:nvSpPr>
           <p:cNvPr id="9" name="text-17"/>
@@ -12669,8 +12577,8 @@
         </p:nvSpPr>
         <p:spPr>
           <a:xfrm>
-            <a:off x="6263640" y="4709160"/>
-            <a:ext cx="5349240" cy="548640"/>
+            <a:off x="822960" y="4846320"/>
+            <a:ext cx="4983480" cy="594360"/>
           </a:xfrm>
           <a:prstGeom prst="rect">
             <a:avLst/>
@@ -12686,14 +12594,543 @@
               <a:buNone/>
             </a:pPr>
             <a:r>
-              <a:rPr lang="en-US" sz="1200" dirty="0">
-                <a:solidFill>
-                  <a:schemeClr val="accent5"/>
-                </a:solidFill>
-              </a:rPr>
-              <a:t>Client window: own view (left), remote peer with live stats (path, safety code, RTT, loss, jitter, freezes)</a:t>
-            </a:r>
-            <a:endParaRPr lang="en-US" sz="1200" dirty="0"/>
+              <a:rPr lang="en-US" sz="1500" b="1" dirty="0">
+                <a:solidFill>
+                  <a:schemeClr val="tx1"/>
+                </a:solidFill>
+              </a:rPr>
+              <a:t>Architecture: </a:t>
+            </a:r>
+            <a:pPr indent="0" marL="0">
+              <a:buNone/>
+            </a:pPr>
+            <a:r>
+              <a:rPr lang="en-US" sz="1500" dirty="0">
+                <a:solidFill>
+                  <a:schemeClr val="tx2"/>
+                </a:solidFill>
+              </a:rPr>
+              <a:t>media path vs signalling path, documented</a:t>
+            </a:r>
+            <a:endParaRPr lang="en-US" sz="1500" dirty="0"/>
+          </a:p>
+        </p:txBody>
+      </p:sp>
+      <p:sp>
+        <p:nvSpPr>
+          <p:cNvPr id="10" name="card-18"/>
+          <p:cNvSpPr/>
+          <p:nvPr/>
+        </p:nvSpPr>
+        <p:spPr>
+          <a:xfrm>
+            <a:off x="6263640" y="1371600"/>
+            <a:ext cx="5349240" cy="4343400"/>
+          </a:xfrm>
+          <a:prstGeom prst="roundRect">
+            <a:avLst>
+              <a:gd name="adj" fmla="val 2526"/>
+            </a:avLst>
+          </a:prstGeom>
+          <a:solidFill>
+            <a:schemeClr val="bg2"/>
+          </a:solidFill>
+          <a:ln/>
+        </p:spPr>
+      </p:sp>
+      <p:sp>
+        <p:nvSpPr>
+          <p:cNvPr id="11" name="text-19"/>
+          <p:cNvSpPr txBox="1"/>
+          <p:nvPr/>
+        </p:nvSpPr>
+        <p:spPr>
+          <a:xfrm>
+            <a:off x="6537960" y="1554480"/>
+            <a:ext cx="4846320" cy="411480"/>
+          </a:xfrm>
+          <a:prstGeom prst="rect">
+            <a:avLst/>
+          </a:prstGeom>
+          <a:noFill/>
+          <a:ln/>
+        </p:spPr>
+        <p:txBody>
+          <a:bodyPr wrap="square" lIns="0" tIns="0" rIns="0" bIns="0" rtlCol="0" anchor="t"/>
+          <a:lstStyle/>
+          <a:p>
+            <a:pPr indent="0" marL="0">
+              <a:buNone/>
+            </a:pPr>
+            <a:r>
+              <a:rPr lang="en-US" sz="1900" b="1" dirty="0">
+                <a:solidFill>
+                  <a:schemeClr val="tx1"/>
+                </a:solidFill>
+              </a:rPr>
+              <a:t>Milestones</a:t>
+            </a:r>
+            <a:endParaRPr lang="en-US" sz="1900" dirty="0"/>
+          </a:p>
+        </p:txBody>
+      </p:sp>
+      <p:sp>
+        <p:nvSpPr>
+          <p:cNvPr id="12" name="badge-20"/>
+          <p:cNvSpPr/>
+          <p:nvPr/>
+        </p:nvSpPr>
+        <p:spPr>
+          <a:xfrm>
+            <a:off x="6537960" y="2148840"/>
+            <a:ext cx="438912" cy="438912"/>
+          </a:xfrm>
+          <a:prstGeom prst="ellipse">
+            <a:avLst/>
+          </a:prstGeom>
+          <a:solidFill>
+            <a:schemeClr val="accent1"/>
+          </a:solidFill>
+          <a:ln/>
+        </p:spPr>
+      </p:sp>
+      <p:sp>
+        <p:nvSpPr>
+          <p:cNvPr id="13" name="badge-text-21"/>
+          <p:cNvSpPr txBox="1"/>
+          <p:nvPr/>
+        </p:nvSpPr>
+        <p:spPr>
+          <a:xfrm>
+            <a:off x="6537960" y="2148840"/>
+            <a:ext cx="438912" cy="438912"/>
+          </a:xfrm>
+          <a:prstGeom prst="rect">
+            <a:avLst/>
+          </a:prstGeom>
+          <a:noFill/>
+          <a:ln/>
+        </p:spPr>
+        <p:txBody>
+          <a:bodyPr wrap="square" lIns="0" tIns="0" rIns="0" bIns="0" rtlCol="0" anchor="ctr"/>
+          <a:lstStyle/>
+          <a:p>
+            <a:pPr algn="ctr" indent="0" marL="0">
+              <a:buNone/>
+            </a:pPr>
+            <a:r>
+              <a:rPr lang="en-US" sz="1500" b="1" dirty="0">
+                <a:solidFill>
+                  <a:schemeClr val="bg1"/>
+                </a:solidFill>
+              </a:rPr>
+              <a:t>1</a:t>
+            </a:r>
+            <a:endParaRPr lang="en-US" sz="1500" dirty="0"/>
+          </a:p>
+        </p:txBody>
+      </p:sp>
+      <p:sp>
+        <p:nvSpPr>
+          <p:cNvPr id="14" name="text-22"/>
+          <p:cNvSpPr txBox="1"/>
+          <p:nvPr/>
+        </p:nvSpPr>
+        <p:spPr>
+          <a:xfrm>
+            <a:off x="7132320" y="2075688"/>
+            <a:ext cx="4297680" cy="685800"/>
+          </a:xfrm>
+          <a:prstGeom prst="rect">
+            <a:avLst/>
+          </a:prstGeom>
+          <a:noFill/>
+          <a:ln/>
+        </p:spPr>
+        <p:txBody>
+          <a:bodyPr wrap="square" lIns="0" tIns="0" rIns="0" bIns="0" rtlCol="0" anchor="t"/>
+          <a:lstStyle/>
+          <a:p>
+            <a:pPr indent="0" marL="0">
+              <a:buNone/>
+            </a:pPr>
+            <a:r>
+              <a:rPr lang="en-US" sz="1500" b="1" dirty="0">
+                <a:solidFill>
+                  <a:schemeClr val="tx1"/>
+                </a:solidFill>
+              </a:rPr>
+              <a:t>Months 1–2</a:t>
+            </a:r>
+            <a:endParaRPr lang="en-US" sz="1500" dirty="0"/>
+          </a:p>
+          <a:p>
+            <a:pPr indent="0" marL="0">
+              <a:buNone/>
+            </a:pPr>
+            <a:r>
+              <a:rPr lang="en-US" sz="1500" dirty="0">
+                <a:solidFill>
+                  <a:schemeClr val="tx2"/>
+                </a:solidFill>
+              </a:rPr>
+              <a:t>signalling server and two-party media path</a:t>
+            </a:r>
+            <a:endParaRPr lang="en-US" sz="1500" dirty="0"/>
+          </a:p>
+        </p:txBody>
+      </p:sp>
+      <p:sp>
+        <p:nvSpPr>
+          <p:cNvPr id="15" name="badge-23"/>
+          <p:cNvSpPr/>
+          <p:nvPr/>
+        </p:nvSpPr>
+        <p:spPr>
+          <a:xfrm>
+            <a:off x="6537960" y="2990088"/>
+            <a:ext cx="438912" cy="438912"/>
+          </a:xfrm>
+          <a:prstGeom prst="ellipse">
+            <a:avLst/>
+          </a:prstGeom>
+          <a:solidFill>
+            <a:schemeClr val="accent1"/>
+          </a:solidFill>
+          <a:ln/>
+        </p:spPr>
+      </p:sp>
+      <p:sp>
+        <p:nvSpPr>
+          <p:cNvPr id="16" name="badge-text-24"/>
+          <p:cNvSpPr txBox="1"/>
+          <p:nvPr/>
+        </p:nvSpPr>
+        <p:spPr>
+          <a:xfrm>
+            <a:off x="6537960" y="2990088"/>
+            <a:ext cx="438912" cy="438912"/>
+          </a:xfrm>
+          <a:prstGeom prst="rect">
+            <a:avLst/>
+          </a:prstGeom>
+          <a:noFill/>
+          <a:ln/>
+        </p:spPr>
+        <p:txBody>
+          <a:bodyPr wrap="square" lIns="0" tIns="0" rIns="0" bIns="0" rtlCol="0" anchor="ctr"/>
+          <a:lstStyle/>
+          <a:p>
+            <a:pPr algn="ctr" indent="0" marL="0">
+              <a:buNone/>
+            </a:pPr>
+            <a:r>
+              <a:rPr lang="en-US" sz="1500" b="1" dirty="0">
+                <a:solidFill>
+                  <a:schemeClr val="bg1"/>
+                </a:solidFill>
+              </a:rPr>
+              <a:t>2</a:t>
+            </a:r>
+            <a:endParaRPr lang="en-US" sz="1500" dirty="0"/>
+          </a:p>
+        </p:txBody>
+      </p:sp>
+      <p:sp>
+        <p:nvSpPr>
+          <p:cNvPr id="17" name="text-25"/>
+          <p:cNvSpPr txBox="1"/>
+          <p:nvPr/>
+        </p:nvSpPr>
+        <p:spPr>
+          <a:xfrm>
+            <a:off x="7132320" y="2916936"/>
+            <a:ext cx="4297680" cy="685800"/>
+          </a:xfrm>
+          <a:prstGeom prst="rect">
+            <a:avLst/>
+          </a:prstGeom>
+          <a:noFill/>
+          <a:ln/>
+        </p:spPr>
+        <p:txBody>
+          <a:bodyPr wrap="square" lIns="0" tIns="0" rIns="0" bIns="0" rtlCol="0" anchor="t"/>
+          <a:lstStyle/>
+          <a:p>
+            <a:pPr indent="0" marL="0">
+              <a:buNone/>
+            </a:pPr>
+            <a:r>
+              <a:rPr lang="en-US" sz="1500" b="1" dirty="0">
+                <a:solidFill>
+                  <a:schemeClr val="tx1"/>
+                </a:solidFill>
+              </a:rPr>
+              <a:t>Months 2–3</a:t>
+            </a:r>
+            <a:endParaRPr lang="en-US" sz="1500" dirty="0"/>
+          </a:p>
+          <a:p>
+            <a:pPr indent="0" marL="0">
+              <a:buNone/>
+            </a:pPr>
+            <a:r>
+              <a:rPr lang="en-US" sz="1500" dirty="0">
+                <a:solidFill>
+                  <a:schemeClr val="tx2"/>
+                </a:solidFill>
+              </a:rPr>
+              <a:t>NAT traversal and multi-party topology</a:t>
+            </a:r>
+            <a:endParaRPr lang="en-US" sz="1500" dirty="0"/>
+          </a:p>
+        </p:txBody>
+      </p:sp>
+      <p:sp>
+        <p:nvSpPr>
+          <p:cNvPr id="18" name="badge-26"/>
+          <p:cNvSpPr/>
+          <p:nvPr/>
+        </p:nvSpPr>
+        <p:spPr>
+          <a:xfrm>
+            <a:off x="6537960" y="3831336"/>
+            <a:ext cx="438912" cy="438912"/>
+          </a:xfrm>
+          <a:prstGeom prst="ellipse">
+            <a:avLst/>
+          </a:prstGeom>
+          <a:solidFill>
+            <a:schemeClr val="accent1"/>
+          </a:solidFill>
+          <a:ln/>
+        </p:spPr>
+      </p:sp>
+      <p:sp>
+        <p:nvSpPr>
+          <p:cNvPr id="19" name="badge-text-27"/>
+          <p:cNvSpPr txBox="1"/>
+          <p:nvPr/>
+        </p:nvSpPr>
+        <p:spPr>
+          <a:xfrm>
+            <a:off x="6537960" y="3831336"/>
+            <a:ext cx="438912" cy="438912"/>
+          </a:xfrm>
+          <a:prstGeom prst="rect">
+            <a:avLst/>
+          </a:prstGeom>
+          <a:noFill/>
+          <a:ln/>
+        </p:spPr>
+        <p:txBody>
+          <a:bodyPr wrap="square" lIns="0" tIns="0" rIns="0" bIns="0" rtlCol="0" anchor="ctr"/>
+          <a:lstStyle/>
+          <a:p>
+            <a:pPr algn="ctr" indent="0" marL="0">
+              <a:buNone/>
+            </a:pPr>
+            <a:r>
+              <a:rPr lang="en-US" sz="1500" b="1" dirty="0">
+                <a:solidFill>
+                  <a:schemeClr val="bg1"/>
+                </a:solidFill>
+              </a:rPr>
+              <a:t>3</a:t>
+            </a:r>
+            <a:endParaRPr lang="en-US" sz="1500" dirty="0"/>
+          </a:p>
+        </p:txBody>
+      </p:sp>
+      <p:sp>
+        <p:nvSpPr>
+          <p:cNvPr id="20" name="text-28"/>
+          <p:cNvSpPr txBox="1"/>
+          <p:nvPr/>
+        </p:nvSpPr>
+        <p:spPr>
+          <a:xfrm>
+            <a:off x="7132320" y="3758184"/>
+            <a:ext cx="4297680" cy="685800"/>
+          </a:xfrm>
+          <a:prstGeom prst="rect">
+            <a:avLst/>
+          </a:prstGeom>
+          <a:noFill/>
+          <a:ln/>
+        </p:spPr>
+        <p:txBody>
+          <a:bodyPr wrap="square" lIns="0" tIns="0" rIns="0" bIns="0" rtlCol="0" anchor="t"/>
+          <a:lstStyle/>
+          <a:p>
+            <a:pPr indent="0" marL="0">
+              <a:buNone/>
+            </a:pPr>
+            <a:r>
+              <a:rPr lang="en-US" sz="1500" b="1" dirty="0">
+                <a:solidFill>
+                  <a:schemeClr val="tx1"/>
+                </a:solidFill>
+              </a:rPr>
+              <a:t>Months 3–4</a:t>
+            </a:r>
+            <a:endParaRPr lang="en-US" sz="1500" dirty="0"/>
+          </a:p>
+          <a:p>
+            <a:pPr indent="0" marL="0">
+              <a:buNone/>
+            </a:pPr>
+            <a:r>
+              <a:rPr lang="en-US" sz="1500" dirty="0">
+                <a:solidFill>
+                  <a:schemeClr val="tx2"/>
+                </a:solidFill>
+              </a:rPr>
+              <a:t>quality instrumentation and adaptation</a:t>
+            </a:r>
+            <a:endParaRPr lang="en-US" sz="1500" dirty="0"/>
+          </a:p>
+        </p:txBody>
+      </p:sp>
+      <p:sp>
+        <p:nvSpPr>
+          <p:cNvPr id="21" name="badge-29"/>
+          <p:cNvSpPr/>
+          <p:nvPr/>
+        </p:nvSpPr>
+        <p:spPr>
+          <a:xfrm>
+            <a:off x="6537960" y="4672584"/>
+            <a:ext cx="438912" cy="438912"/>
+          </a:xfrm>
+          <a:prstGeom prst="ellipse">
+            <a:avLst/>
+          </a:prstGeom>
+          <a:solidFill>
+            <a:schemeClr val="accent1"/>
+          </a:solidFill>
+          <a:ln/>
+        </p:spPr>
+      </p:sp>
+      <p:sp>
+        <p:nvSpPr>
+          <p:cNvPr id="22" name="badge-text-30"/>
+          <p:cNvSpPr txBox="1"/>
+          <p:nvPr/>
+        </p:nvSpPr>
+        <p:spPr>
+          <a:xfrm>
+            <a:off x="6537960" y="4672584"/>
+            <a:ext cx="438912" cy="438912"/>
+          </a:xfrm>
+          <a:prstGeom prst="rect">
+            <a:avLst/>
+          </a:prstGeom>
+          <a:noFill/>
+          <a:ln/>
+        </p:spPr>
+        <p:txBody>
+          <a:bodyPr wrap="square" lIns="0" tIns="0" rIns="0" bIns="0" rtlCol="0" anchor="ctr"/>
+          <a:lstStyle/>
+          <a:p>
+            <a:pPr algn="ctr" indent="0" marL="0">
+              <a:buNone/>
+            </a:pPr>
+            <a:r>
+              <a:rPr lang="en-US" sz="1500" b="1" dirty="0">
+                <a:solidFill>
+                  <a:schemeClr val="bg1"/>
+                </a:solidFill>
+              </a:rPr>
+              <a:t>4</a:t>
+            </a:r>
+            <a:endParaRPr lang="en-US" sz="1500" dirty="0"/>
+          </a:p>
+        </p:txBody>
+      </p:sp>
+      <p:sp>
+        <p:nvSpPr>
+          <p:cNvPr id="23" name="text-31"/>
+          <p:cNvSpPr txBox="1"/>
+          <p:nvPr/>
+        </p:nvSpPr>
+        <p:spPr>
+          <a:xfrm>
+            <a:off x="7132320" y="4599432"/>
+            <a:ext cx="4297680" cy="685800"/>
+          </a:xfrm>
+          <a:prstGeom prst="rect">
+            <a:avLst/>
+          </a:prstGeom>
+          <a:noFill/>
+          <a:ln/>
+        </p:spPr>
+        <p:txBody>
+          <a:bodyPr wrap="square" lIns="0" tIns="0" rIns="0" bIns="0" rtlCol="0" anchor="t"/>
+          <a:lstStyle/>
+          <a:p>
+            <a:pPr indent="0" marL="0">
+              <a:buNone/>
+            </a:pPr>
+            <a:r>
+              <a:rPr lang="en-US" sz="1500" b="1" dirty="0">
+                <a:solidFill>
+                  <a:schemeClr val="tx1"/>
+                </a:solidFill>
+              </a:rPr>
+              <a:t>Months 5–6</a:t>
+            </a:r>
+            <a:endParaRPr lang="en-US" sz="1500" dirty="0"/>
+          </a:p>
+          <a:p>
+            <a:pPr indent="0" marL="0">
+              <a:buNone/>
+            </a:pPr>
+            <a:r>
+              <a:rPr lang="en-US" sz="1500" dirty="0">
+                <a:solidFill>
+                  <a:schemeClr val="tx2"/>
+                </a:solidFill>
+              </a:rPr>
+              <a:t>impairment evaluation, report and viva</a:t>
+            </a:r>
+            <a:endParaRPr lang="en-US" sz="1500" dirty="0"/>
+          </a:p>
+        </p:txBody>
+      </p:sp>
+      <p:sp>
+        <p:nvSpPr>
+          <p:cNvPr id="24" name="text-32"/>
+          <p:cNvSpPr txBox="1"/>
+          <p:nvPr/>
+        </p:nvSpPr>
+        <p:spPr>
+          <a:xfrm>
+            <a:off x="548640" y="5897880"/>
+            <a:ext cx="11064240" cy="320040"/>
+          </a:xfrm>
+          <a:prstGeom prst="rect">
+            <a:avLst/>
+          </a:prstGeom>
+          <a:noFill/>
+          <a:ln/>
+        </p:spPr>
+        <p:txBody>
+          <a:bodyPr wrap="square" lIns="0" tIns="0" rIns="0" bIns="0" rtlCol="0" anchor="t"/>
+          <a:lstStyle/>
+          <a:p>
+            <a:pPr indent="0" marL="0">
+              <a:buNone/>
+            </a:pPr>
+            <a:r>
+              <a:rPr lang="en-US" sz="1500" i="1" dirty="0">
+                <a:solidFill>
+                  <a:schemeClr val="accent1"/>
+                </a:solidFill>
+              </a:rPr>
+              <a:t>Also built: end-to-end encryption · adaptive jitter buffer · Windows + Linux · 72 unit-test checks</a:t>
+            </a:r>
+            <a:endParaRPr lang="en-US" sz="1500" dirty="0"/>
           </a:p>
         </p:txBody>
       </p:sp>
@@ -12807,7 +13244,7 @@
       </p:sp>
       <p:sp>
         <p:nvSpPr>
-          <p:cNvPr id="3" name="server-18"/>
+          <p:cNvPr id="3" name="server-33"/>
           <p:cNvSpPr/>
           <p:nvPr/>
         </p:nvSpPr>
@@ -12829,7 +13266,7 @@
       </p:sp>
       <p:sp>
         <p:nvSpPr>
-          <p:cNvPr id="4" name="text-19"/>
+          <p:cNvPr id="4" name="text-34"/>
           <p:cNvSpPr txBox="1"/>
           <p:nvPr/>
         </p:nvSpPr>
@@ -12879,7 +13316,7 @@
       </p:sp>
       <p:sp>
         <p:nvSpPr>
-          <p:cNvPr id="5" name="peer-20"/>
+          <p:cNvPr id="5" name="peer-35"/>
           <p:cNvSpPr/>
           <p:nvPr/>
         </p:nvSpPr>
@@ -12906,7 +13343,7 @@
       </p:sp>
       <p:sp>
         <p:nvSpPr>
-          <p:cNvPr id="6" name="text-21"/>
+          <p:cNvPr id="6" name="text-36"/>
           <p:cNvSpPr txBox="1"/>
           <p:nvPr/>
         </p:nvSpPr>
@@ -12934,7 +13371,7 @@
                   <a:schemeClr val="tx1"/>
                 </a:solidFill>
               </a:rPr>
-              <a:t>mm (Alice)</a:t>
+              <a:t>mm (PC1)</a:t>
             </a:r>
             <a:endParaRPr lang="en-US" sz="1600" dirty="0"/>
           </a:p>
@@ -12956,7 +13393,7 @@
       </p:sp>
       <p:sp>
         <p:nvSpPr>
-          <p:cNvPr id="7" name="peer-22"/>
+          <p:cNvPr id="7" name="peer-37"/>
           <p:cNvSpPr/>
           <p:nvPr/>
         </p:nvSpPr>
@@ -12983,7 +13420,7 @@
       </p:sp>
       <p:sp>
         <p:nvSpPr>
-          <p:cNvPr id="8" name="text-23"/>
+          <p:cNvPr id="8" name="text-38"/>
           <p:cNvSpPr txBox="1"/>
           <p:nvPr/>
         </p:nvSpPr>
@@ -13011,7 +13448,7 @@
                   <a:schemeClr val="tx1"/>
                 </a:solidFill>
               </a:rPr>
-              <a:t>mm (Bob)</a:t>
+              <a:t>mm (PC2)</a:t>
             </a:r>
             <a:endParaRPr lang="en-US" sz="1600" dirty="0"/>
           </a:p>
@@ -13033,7 +13470,7 @@
       </p:sp>
       <p:sp>
         <p:nvSpPr>
-          <p:cNvPr id="9" name="tcp-24"/>
+          <p:cNvPr id="9" name="tcp-39"/>
           <p:cNvSpPr/>
           <p:nvPr/>
         </p:nvSpPr>
@@ -13058,7 +13495,7 @@
       </p:sp>
       <p:sp>
         <p:nvSpPr>
-          <p:cNvPr id="10" name="tcp-25"/>
+          <p:cNvPr id="10" name="tcp-40"/>
           <p:cNvSpPr/>
           <p:nvPr/>
         </p:nvSpPr>
@@ -13083,7 +13520,7 @@
       </p:sp>
       <p:sp>
         <p:nvSpPr>
-          <p:cNvPr id="11" name="udp-26"/>
+          <p:cNvPr id="11" name="udp-41"/>
           <p:cNvSpPr/>
           <p:nvPr/>
         </p:nvSpPr>
@@ -13108,7 +13545,7 @@
       </p:sp>
       <p:sp>
         <p:nvSpPr>
-          <p:cNvPr id="12" name="text-27"/>
+          <p:cNvPr id="12" name="text-42"/>
           <p:cNvSpPr txBox="1"/>
           <p:nvPr/>
         </p:nvSpPr>
@@ -13144,7 +13581,7 @@
       </p:sp>
       <p:sp>
         <p:nvSpPr>
-          <p:cNvPr id="13" name="text-28"/>
+          <p:cNvPr id="13" name="text-43"/>
           <p:cNvSpPr txBox="1"/>
           <p:nvPr/>
         </p:nvSpPr>
@@ -13180,7 +13617,7 @@
       </p:sp>
       <p:sp>
         <p:nvSpPr>
-          <p:cNvPr id="14" name="card-29"/>
+          <p:cNvPr id="14" name="card-44"/>
           <p:cNvSpPr/>
           <p:nvPr/>
         </p:nvSpPr>
@@ -13202,7 +13639,7 @@
       </p:sp>
       <p:sp>
         <p:nvSpPr>
-          <p:cNvPr id="15" name="text-30"/>
+          <p:cNvPr id="15" name="text-45"/>
           <p:cNvSpPr txBox="1"/>
           <p:nvPr/>
         </p:nvSpPr>
@@ -13238,7 +13675,7 @@
       </p:sp>
       <p:sp>
         <p:nvSpPr>
-          <p:cNvPr id="16" name="text-31"/>
+          <p:cNvPr id="16" name="text-46"/>
           <p:cNvSpPr txBox="1"/>
           <p:nvPr/>
         </p:nvSpPr>
@@ -13274,7 +13711,7 @@
       </p:sp>
       <p:sp>
         <p:nvSpPr>
-          <p:cNvPr id="17" name="card-32"/>
+          <p:cNvPr id="17" name="card-47"/>
           <p:cNvSpPr/>
           <p:nvPr/>
         </p:nvSpPr>
@@ -13296,7 +13733,7 @@
       </p:sp>
       <p:sp>
         <p:nvSpPr>
-          <p:cNvPr id="18" name="text-33"/>
+          <p:cNvPr id="18" name="text-48"/>
           <p:cNvSpPr txBox="1"/>
           <p:nvPr/>
         </p:nvSpPr>
@@ -13332,7 +13769,7 @@
       </p:sp>
       <p:sp>
         <p:nvSpPr>
-          <p:cNvPr id="19" name="text-34"/>
+          <p:cNvPr id="19" name="text-49"/>
           <p:cNvSpPr txBox="1"/>
           <p:nvPr/>
         </p:nvSpPr>
@@ -13368,7 +13805,7 @@
       </p:sp>
       <p:sp>
         <p:nvSpPr>
-          <p:cNvPr id="20" name="card-35"/>
+          <p:cNvPr id="20" name="card-50"/>
           <p:cNvSpPr/>
           <p:nvPr/>
         </p:nvSpPr>
@@ -13390,7 +13827,7 @@
       </p:sp>
       <p:sp>
         <p:nvSpPr>
-          <p:cNvPr id="21" name="text-36"/>
+          <p:cNvPr id="21" name="text-51"/>
           <p:cNvSpPr txBox="1"/>
           <p:nvPr/>
         </p:nvSpPr>
@@ -13426,7 +13863,7 @@
       </p:sp>
       <p:sp>
         <p:nvSpPr>
-          <p:cNvPr id="22" name="text-37"/>
+          <p:cNvPr id="22" name="text-52"/>
           <p:cNvSpPr txBox="1"/>
           <p:nvPr/>
         </p:nvSpPr>
@@ -13570,7 +14007,7 @@
       </p:sp>
       <p:sp>
         <p:nvSpPr>
-          <p:cNvPr id="3" name="console-38"/>
+          <p:cNvPr id="3" name="console-53"/>
           <p:cNvSpPr/>
           <p:nvPr/>
         </p:nvSpPr>
@@ -13592,7 +14029,7 @@
       </p:sp>
       <p:sp>
         <p:nvSpPr>
-          <p:cNvPr id="4" name="text-39"/>
+          <p:cNvPr id="4" name="text-54"/>
           <p:cNvSpPr txBox="1"/>
           <p:nvPr/>
         </p:nvSpPr>
@@ -13626,7 +14063,7 @@
                 <a:ea typeface="Consolas" pitchFamily="34" charset="-122"/>
                 <a:cs typeface="Consolas" pitchFamily="34" charset="-120"/>
               </a:rPr>
-              <a:t>→ JOIN demo carol</a:t>
+              <a:t>→ JOIN demo pc3</a:t>
             </a:r>
             <a:endParaRPr lang="en-US" sz="1700" dirty="0"/>
           </a:p>
@@ -13646,7 +14083,7 @@
                 <a:ea typeface="Consolas" pitchFamily="34" charset="-122"/>
                 <a:cs typeface="Consolas" pitchFamily="34" charset="-120"/>
               </a:rPr>
-              <a:t>← JOINED c1 demo a1:alice</a:t>
+              <a:t>← JOINED c1 demo a1:pc1</a:t>
             </a:r>
             <a:endParaRPr lang="en-US" sz="1700" dirty="0"/>
           </a:p>
@@ -13774,7 +14211,7 @@
       </p:sp>
       <p:sp>
         <p:nvSpPr>
-          <p:cNvPr id="5" name="badge-40"/>
+          <p:cNvPr id="5" name="badge-55"/>
           <p:cNvSpPr/>
           <p:nvPr/>
         </p:nvSpPr>
@@ -13794,7 +14231,7 @@
       </p:sp>
       <p:sp>
         <p:nvSpPr>
-          <p:cNvPr id="6" name="badge-text-41"/>
+          <p:cNvPr id="6" name="badge-text-56"/>
           <p:cNvSpPr txBox="1"/>
           <p:nvPr/>
         </p:nvSpPr>
@@ -13830,7 +14267,7 @@
       </p:sp>
       <p:sp>
         <p:nvSpPr>
-          <p:cNvPr id="7" name="text-42"/>
+          <p:cNvPr id="7" name="text-57"/>
           <p:cNvSpPr txBox="1"/>
           <p:nvPr/>
         </p:nvSpPr>
@@ -13866,7 +14303,7 @@
       </p:sp>
       <p:sp>
         <p:nvSpPr>
-          <p:cNvPr id="8" name="text-43"/>
+          <p:cNvPr id="8" name="text-58"/>
           <p:cNvSpPr txBox="1"/>
           <p:nvPr/>
         </p:nvSpPr>
@@ -13902,7 +14339,7 @@
       </p:sp>
       <p:sp>
         <p:nvSpPr>
-          <p:cNvPr id="9" name="badge-44"/>
+          <p:cNvPr id="9" name="badge-59"/>
           <p:cNvSpPr/>
           <p:nvPr/>
         </p:nvSpPr>
@@ -13922,7 +14359,7 @@
       </p:sp>
       <p:sp>
         <p:nvSpPr>
-          <p:cNvPr id="10" name="badge-text-45"/>
+          <p:cNvPr id="10" name="badge-text-60"/>
           <p:cNvSpPr txBox="1"/>
           <p:nvPr/>
         </p:nvSpPr>
@@ -13958,7 +14395,7 @@
       </p:sp>
       <p:sp>
         <p:nvSpPr>
-          <p:cNvPr id="11" name="text-46"/>
+          <p:cNvPr id="11" name="text-61"/>
           <p:cNvSpPr txBox="1"/>
           <p:nvPr/>
         </p:nvSpPr>
@@ -13994,7 +14431,7 @@
       </p:sp>
       <p:sp>
         <p:nvSpPr>
-          <p:cNvPr id="12" name="text-47"/>
+          <p:cNvPr id="12" name="text-62"/>
           <p:cNvSpPr txBox="1"/>
           <p:nvPr/>
         </p:nvSpPr>
@@ -14030,7 +14467,7 @@
       </p:sp>
       <p:sp>
         <p:nvSpPr>
-          <p:cNvPr id="13" name="badge-48"/>
+          <p:cNvPr id="13" name="badge-63"/>
           <p:cNvSpPr/>
           <p:nvPr/>
         </p:nvSpPr>
@@ -14050,7 +14487,7 @@
       </p:sp>
       <p:sp>
         <p:nvSpPr>
-          <p:cNvPr id="14" name="badge-text-49"/>
+          <p:cNvPr id="14" name="badge-text-64"/>
           <p:cNvSpPr txBox="1"/>
           <p:nvPr/>
         </p:nvSpPr>
@@ -14086,7 +14523,7 @@
       </p:sp>
       <p:sp>
         <p:nvSpPr>
-          <p:cNvPr id="15" name="text-50"/>
+          <p:cNvPr id="15" name="text-65"/>
           <p:cNvSpPr txBox="1"/>
           <p:nvPr/>
         </p:nvSpPr>
@@ -14122,7 +14559,7 @@
       </p:sp>
       <p:sp>
         <p:nvSpPr>
-          <p:cNvPr id="16" name="text-51"/>
+          <p:cNvPr id="16" name="text-66"/>
           <p:cNvSpPr txBox="1"/>
           <p:nvPr/>
         </p:nvSpPr>
@@ -14158,7 +14595,7 @@
       </p:sp>
       <p:sp>
         <p:nvSpPr>
-          <p:cNvPr id="17" name="badge-52"/>
+          <p:cNvPr id="17" name="badge-67"/>
           <p:cNvSpPr/>
           <p:nvPr/>
         </p:nvSpPr>
@@ -14178,7 +14615,7 @@
       </p:sp>
       <p:sp>
         <p:nvSpPr>
-          <p:cNvPr id="18" name="badge-text-53"/>
+          <p:cNvPr id="18" name="badge-text-68"/>
           <p:cNvSpPr txBox="1"/>
           <p:nvPr/>
         </p:nvSpPr>
@@ -14214,7 +14651,7 @@
       </p:sp>
       <p:sp>
         <p:nvSpPr>
-          <p:cNvPr id="19" name="text-54"/>
+          <p:cNvPr id="19" name="text-69"/>
           <p:cNvSpPr txBox="1"/>
           <p:nvPr/>
         </p:nvSpPr>
@@ -14250,7 +14687,7 @@
       </p:sp>
       <p:sp>
         <p:nvSpPr>
-          <p:cNvPr id="20" name="text-55"/>
+          <p:cNvPr id="20" name="text-70"/>
           <p:cNvSpPr txBox="1"/>
           <p:nvPr/>
         </p:nvSpPr>
@@ -14394,7 +14831,7 @@
       </p:sp>
       <p:sp>
         <p:nvSpPr>
-          <p:cNvPr id="3" name="card-56"/>
+          <p:cNvPr id="3" name="card-71"/>
           <p:cNvSpPr/>
           <p:nvPr/>
         </p:nvSpPr>
@@ -14416,7 +14853,7 @@
       </p:sp>
       <p:sp>
         <p:nvSpPr>
-          <p:cNvPr id="4" name="badge-57"/>
+          <p:cNvPr id="4" name="badge-72"/>
           <p:cNvSpPr/>
           <p:nvPr/>
         </p:nvSpPr>
@@ -14436,7 +14873,7 @@
       </p:sp>
       <p:sp>
         <p:nvSpPr>
-          <p:cNvPr id="5" name="badge-text-58"/>
+          <p:cNvPr id="5" name="badge-text-73"/>
           <p:cNvSpPr txBox="1"/>
           <p:nvPr/>
         </p:nvSpPr>
@@ -14472,7 +14909,7 @@
       </p:sp>
       <p:sp>
         <p:nvSpPr>
-          <p:cNvPr id="6" name="text-59"/>
+          <p:cNvPr id="6" name="text-74"/>
           <p:cNvSpPr txBox="1"/>
           <p:nvPr/>
         </p:nvSpPr>
@@ -14508,7 +14945,7 @@
       </p:sp>
       <p:sp>
         <p:nvSpPr>
-          <p:cNvPr id="7" name="text-60"/>
+          <p:cNvPr id="7" name="text-75"/>
           <p:cNvSpPr txBox="1"/>
           <p:nvPr/>
         </p:nvSpPr>
@@ -14544,7 +14981,7 @@
       </p:sp>
       <p:sp>
         <p:nvSpPr>
-          <p:cNvPr id="8" name="arrow-61"/>
+          <p:cNvPr id="8" name="arrow-76"/>
           <p:cNvSpPr/>
           <p:nvPr/>
         </p:nvSpPr>
@@ -14568,7 +15005,7 @@
       </p:sp>
       <p:sp>
         <p:nvSpPr>
-          <p:cNvPr id="9" name="card-62"/>
+          <p:cNvPr id="9" name="card-77"/>
           <p:cNvSpPr/>
           <p:nvPr/>
         </p:nvSpPr>
@@ -14590,7 +15027,7 @@
       </p:sp>
       <p:sp>
         <p:nvSpPr>
-          <p:cNvPr id="10" name="badge-63"/>
+          <p:cNvPr id="10" name="badge-78"/>
           <p:cNvSpPr/>
           <p:nvPr/>
         </p:nvSpPr>
@@ -14610,7 +15047,7 @@
       </p:sp>
       <p:sp>
         <p:nvSpPr>
-          <p:cNvPr id="11" name="badge-text-64"/>
+          <p:cNvPr id="11" name="badge-text-79"/>
           <p:cNvSpPr txBox="1"/>
           <p:nvPr/>
         </p:nvSpPr>
@@ -14646,7 +15083,7 @@
       </p:sp>
       <p:sp>
         <p:nvSpPr>
-          <p:cNvPr id="12" name="text-65"/>
+          <p:cNvPr id="12" name="text-80"/>
           <p:cNvSpPr txBox="1"/>
           <p:nvPr/>
         </p:nvSpPr>
@@ -14682,7 +15119,7 @@
       </p:sp>
       <p:sp>
         <p:nvSpPr>
-          <p:cNvPr id="13" name="text-66"/>
+          <p:cNvPr id="13" name="text-81"/>
           <p:cNvSpPr txBox="1"/>
           <p:nvPr/>
         </p:nvSpPr>
@@ -14718,7 +15155,7 @@
       </p:sp>
       <p:sp>
         <p:nvSpPr>
-          <p:cNvPr id="14" name="arrow-67"/>
+          <p:cNvPr id="14" name="arrow-82"/>
           <p:cNvSpPr/>
           <p:nvPr/>
         </p:nvSpPr>
@@ -14742,7 +15179,7 @@
       </p:sp>
       <p:sp>
         <p:nvSpPr>
-          <p:cNvPr id="15" name="card-68"/>
+          <p:cNvPr id="15" name="card-83"/>
           <p:cNvSpPr/>
           <p:nvPr/>
         </p:nvSpPr>
@@ -14764,7 +15201,7 @@
       </p:sp>
       <p:sp>
         <p:nvSpPr>
-          <p:cNvPr id="16" name="badge-69"/>
+          <p:cNvPr id="16" name="badge-84"/>
           <p:cNvSpPr/>
           <p:nvPr/>
         </p:nvSpPr>
@@ -14784,7 +15221,7 @@
       </p:sp>
       <p:sp>
         <p:nvSpPr>
-          <p:cNvPr id="17" name="badge-text-70"/>
+          <p:cNvPr id="17" name="badge-text-85"/>
           <p:cNvSpPr txBox="1"/>
           <p:nvPr/>
         </p:nvSpPr>
@@ -14820,7 +15257,7 @@
       </p:sp>
       <p:sp>
         <p:nvSpPr>
-          <p:cNvPr id="18" name="text-71"/>
+          <p:cNvPr id="18" name="text-86"/>
           <p:cNvSpPr txBox="1"/>
           <p:nvPr/>
         </p:nvSpPr>
@@ -14856,7 +15293,7 @@
       </p:sp>
       <p:sp>
         <p:nvSpPr>
-          <p:cNvPr id="19" name="text-72"/>
+          <p:cNvPr id="19" name="text-87"/>
           <p:cNvSpPr txBox="1"/>
           <p:nvPr/>
         </p:nvSpPr>
@@ -14892,7 +15329,7 @@
       </p:sp>
       <p:sp>
         <p:nvSpPr>
-          <p:cNvPr id="20" name="arrow-73"/>
+          <p:cNvPr id="20" name="arrow-88"/>
           <p:cNvSpPr/>
           <p:nvPr/>
         </p:nvSpPr>
@@ -14916,7 +15353,7 @@
       </p:sp>
       <p:sp>
         <p:nvSpPr>
-          <p:cNvPr id="21" name="card-74"/>
+          <p:cNvPr id="21" name="card-89"/>
           <p:cNvSpPr/>
           <p:nvPr/>
         </p:nvSpPr>
@@ -14938,7 +15375,7 @@
       </p:sp>
       <p:sp>
         <p:nvSpPr>
-          <p:cNvPr id="22" name="badge-75"/>
+          <p:cNvPr id="22" name="badge-90"/>
           <p:cNvSpPr/>
           <p:nvPr/>
         </p:nvSpPr>
@@ -14958,7 +15395,7 @@
       </p:sp>
       <p:sp>
         <p:nvSpPr>
-          <p:cNvPr id="23" name="badge-text-76"/>
+          <p:cNvPr id="23" name="badge-text-91"/>
           <p:cNvSpPr txBox="1"/>
           <p:nvPr/>
         </p:nvSpPr>
@@ -14994,7 +15431,7 @@
       </p:sp>
       <p:sp>
         <p:nvSpPr>
-          <p:cNvPr id="24" name="text-77"/>
+          <p:cNvPr id="24" name="text-92"/>
           <p:cNvSpPr txBox="1"/>
           <p:nvPr/>
         </p:nvSpPr>
@@ -15030,7 +15467,7 @@
       </p:sp>
       <p:sp>
         <p:nvSpPr>
-          <p:cNvPr id="25" name="text-78"/>
+          <p:cNvPr id="25" name="text-93"/>
           <p:cNvSpPr txBox="1"/>
           <p:nvPr/>
         </p:nvSpPr>
@@ -15066,7 +15503,7 @@
       </p:sp>
       <p:sp>
         <p:nvSpPr>
-          <p:cNvPr id="26" name="card-79"/>
+          <p:cNvPr id="26" name="card-94"/>
           <p:cNvSpPr/>
           <p:nvPr/>
         </p:nvSpPr>
@@ -15088,7 +15525,7 @@
       </p:sp>
       <p:sp>
         <p:nvSpPr>
-          <p:cNvPr id="27" name="text-80"/>
+          <p:cNvPr id="27" name="text-95"/>
           <p:cNvSpPr txBox="1"/>
           <p:nvPr/>
         </p:nvSpPr>
@@ -15124,7 +15561,7 @@
       </p:sp>
       <p:sp>
         <p:nvSpPr>
-          <p:cNvPr id="28" name="text-81"/>
+          <p:cNvPr id="28" name="text-96"/>
           <p:cNvSpPr txBox="1"/>
           <p:nvPr/>
         </p:nvSpPr>
@@ -15160,7 +15597,7 @@
       </p:sp>
       <p:sp>
         <p:nvSpPr>
-          <p:cNvPr id="29" name="card-82"/>
+          <p:cNvPr id="29" name="card-97"/>
           <p:cNvSpPr/>
           <p:nvPr/>
         </p:nvSpPr>
@@ -15182,7 +15619,7 @@
       </p:sp>
       <p:sp>
         <p:nvSpPr>
-          <p:cNvPr id="30" name="text-83"/>
+          <p:cNvPr id="30" name="text-98"/>
           <p:cNvSpPr txBox="1"/>
           <p:nvPr/>
         </p:nvSpPr>
@@ -15218,7 +15655,7 @@
       </p:sp>
       <p:sp>
         <p:nvSpPr>
-          <p:cNvPr id="31" name="text-84"/>
+          <p:cNvPr id="31" name="text-99"/>
           <p:cNvSpPr txBox="1"/>
           <p:nvPr/>
         </p:nvSpPr>
@@ -15362,7 +15799,7 @@
       </p:sp>
       <p:sp>
         <p:nvSpPr>
-          <p:cNvPr id="3" name="field-85"/>
+          <p:cNvPr id="3" name="field-100"/>
           <p:cNvSpPr/>
           <p:nvPr/>
         </p:nvSpPr>
@@ -15387,7 +15824,7 @@
       </p:sp>
       <p:sp>
         <p:nvSpPr>
-          <p:cNvPr id="4" name="text-86"/>
+          <p:cNvPr id="4" name="text-101"/>
           <p:cNvSpPr txBox="1"/>
           <p:nvPr/>
         </p:nvSpPr>
@@ -15423,7 +15860,7 @@
       </p:sp>
       <p:sp>
         <p:nvSpPr>
-          <p:cNvPr id="5" name="field-87"/>
+          <p:cNvPr id="5" name="field-102"/>
           <p:cNvSpPr/>
           <p:nvPr/>
         </p:nvSpPr>
@@ -15448,7 +15885,7 @@
       </p:sp>
       <p:sp>
         <p:nvSpPr>
-          <p:cNvPr id="6" name="text-88"/>
+          <p:cNvPr id="6" name="text-103"/>
           <p:cNvSpPr txBox="1"/>
           <p:nvPr/>
         </p:nvSpPr>
@@ -15484,7 +15921,7 @@
       </p:sp>
       <p:sp>
         <p:nvSpPr>
-          <p:cNvPr id="7" name="field-89"/>
+          <p:cNvPr id="7" name="field-104"/>
           <p:cNvSpPr/>
           <p:nvPr/>
         </p:nvSpPr>
@@ -15509,7 +15946,7 @@
       </p:sp>
       <p:sp>
         <p:nvSpPr>
-          <p:cNvPr id="8" name="text-90"/>
+          <p:cNvPr id="8" name="text-105"/>
           <p:cNvSpPr txBox="1"/>
           <p:nvPr/>
         </p:nvSpPr>
@@ -15545,7 +15982,7 @@
       </p:sp>
       <p:sp>
         <p:nvSpPr>
-          <p:cNvPr id="9" name="field-91"/>
+          <p:cNvPr id="9" name="field-106"/>
           <p:cNvSpPr/>
           <p:nvPr/>
         </p:nvSpPr>
@@ -15570,7 +16007,7 @@
       </p:sp>
       <p:sp>
         <p:nvSpPr>
-          <p:cNvPr id="10" name="text-92"/>
+          <p:cNvPr id="10" name="text-107"/>
           <p:cNvSpPr txBox="1"/>
           <p:nvPr/>
         </p:nvSpPr>
@@ -15606,7 +16043,7 @@
       </p:sp>
       <p:sp>
         <p:nvSpPr>
-          <p:cNvPr id="11" name="field-93"/>
+          <p:cNvPr id="11" name="field-108"/>
           <p:cNvSpPr/>
           <p:nvPr/>
         </p:nvSpPr>
@@ -15631,7 +16068,7 @@
       </p:sp>
       <p:sp>
         <p:nvSpPr>
-          <p:cNvPr id="12" name="text-94"/>
+          <p:cNvPr id="12" name="text-109"/>
           <p:cNvSpPr txBox="1"/>
           <p:nvPr/>
         </p:nvSpPr>
@@ -15667,7 +16104,7 @@
       </p:sp>
       <p:sp>
         <p:nvSpPr>
-          <p:cNvPr id="13" name="field-95"/>
+          <p:cNvPr id="13" name="field-110"/>
           <p:cNvSpPr/>
           <p:nvPr/>
         </p:nvSpPr>
@@ -15692,7 +16129,7 @@
       </p:sp>
       <p:sp>
         <p:nvSpPr>
-          <p:cNvPr id="14" name="text-96"/>
+          <p:cNvPr id="14" name="text-111"/>
           <p:cNvSpPr txBox="1"/>
           <p:nvPr/>
         </p:nvSpPr>
@@ -15728,7 +16165,7 @@
       </p:sp>
       <p:sp>
         <p:nvSpPr>
-          <p:cNvPr id="15" name="field-97"/>
+          <p:cNvPr id="15" name="field-112"/>
           <p:cNvSpPr/>
           <p:nvPr/>
         </p:nvSpPr>
@@ -15753,7 +16190,7 @@
       </p:sp>
       <p:sp>
         <p:nvSpPr>
-          <p:cNvPr id="16" name="text-98"/>
+          <p:cNvPr id="16" name="text-113"/>
           <p:cNvSpPr txBox="1"/>
           <p:nvPr/>
         </p:nvSpPr>
@@ -15789,7 +16226,7 @@
       </p:sp>
       <p:sp>
         <p:nvSpPr>
-          <p:cNvPr id="17" name="field-99"/>
+          <p:cNvPr id="17" name="field-114"/>
           <p:cNvSpPr/>
           <p:nvPr/>
         </p:nvSpPr>
@@ -15814,7 +16251,7 @@
       </p:sp>
       <p:sp>
         <p:nvSpPr>
-          <p:cNvPr id="18" name="text-100"/>
+          <p:cNvPr id="18" name="text-115"/>
           <p:cNvSpPr txBox="1"/>
           <p:nvPr/>
         </p:nvSpPr>
@@ -15850,7 +16287,7 @@
       </p:sp>
       <p:sp>
         <p:nvSpPr>
-          <p:cNvPr id="19" name="text-101"/>
+          <p:cNvPr id="19" name="text-116"/>
           <p:cNvSpPr txBox="1"/>
           <p:nvPr/>
         </p:nvSpPr>
@@ -15886,7 +16323,7 @@
       </p:sp>
       <p:graphicFrame>
         <p:nvGraphicFramePr>
-          <p:cNvPr id="7" name="pt-table-102"/>
+          <p:cNvPr id="7" name="pt-table-117"/>
           <p:cNvGraphicFramePr>
             <a:graphicFrameLocks noGrp="1"/>
           </p:cNvGraphicFramePr>
@@ -16630,7 +17067,7 @@
       </p:graphicFrame>
       <p:sp>
         <p:nvSpPr>
-          <p:cNvPr id="21" name="card-103"/>
+          <p:cNvPr id="21" name="card-118"/>
           <p:cNvSpPr/>
           <p:nvPr/>
         </p:nvSpPr>
@@ -16652,7 +17089,7 @@
       </p:sp>
       <p:sp>
         <p:nvSpPr>
-          <p:cNvPr id="22" name="text-104"/>
+          <p:cNvPr id="22" name="text-119"/>
           <p:cNvSpPr txBox="1"/>
           <p:nvPr/>
         </p:nvSpPr>
@@ -16688,7 +17125,7 @@
       </p:sp>
       <p:sp>
         <p:nvSpPr>
-          <p:cNvPr id="23" name="list-105"/>
+          <p:cNvPr id="23" name="list-120"/>
           <p:cNvSpPr txBox="1"/>
           <p:nvPr/>
         </p:nvSpPr>
@@ -16872,7 +17309,7 @@
       </p:sp>
       <p:sp>
         <p:nvSpPr>
-          <p:cNvPr id="3" name="card-106"/>
+          <p:cNvPr id="3" name="card-121"/>
           <p:cNvSpPr/>
           <p:nvPr/>
         </p:nvSpPr>
@@ -16894,7 +17331,7 @@
       </p:sp>
       <p:sp>
         <p:nvSpPr>
-          <p:cNvPr id="4" name="text-107"/>
+          <p:cNvPr id="4" name="text-122"/>
           <p:cNvSpPr txBox="1"/>
           <p:nvPr/>
         </p:nvSpPr>
@@ -16944,7 +17381,7 @@
       </p:sp>
       <p:sp>
         <p:nvSpPr>
-          <p:cNvPr id="5" name="text-108"/>
+          <p:cNvPr id="5" name="text-123"/>
           <p:cNvSpPr txBox="1"/>
           <p:nvPr/>
         </p:nvSpPr>
@@ -16983,7 +17420,7 @@
       </p:sp>
       <p:sp>
         <p:nvSpPr>
-          <p:cNvPr id="6" name="text-109"/>
+          <p:cNvPr id="6" name="text-124"/>
           <p:cNvSpPr txBox="1"/>
           <p:nvPr/>
         </p:nvSpPr>
@@ -17019,7 +17456,7 @@
       </p:sp>
       <p:sp>
         <p:nvSpPr>
-          <p:cNvPr id="7" name="text-110"/>
+          <p:cNvPr id="7" name="text-125"/>
           <p:cNvSpPr txBox="1"/>
           <p:nvPr/>
         </p:nvSpPr>
@@ -17058,7 +17495,7 @@
       </p:sp>
       <p:sp>
         <p:nvSpPr>
-          <p:cNvPr id="8" name="text-111"/>
+          <p:cNvPr id="8" name="text-126"/>
           <p:cNvSpPr txBox="1"/>
           <p:nvPr/>
         </p:nvSpPr>
@@ -17094,7 +17531,7 @@
       </p:sp>
       <p:sp>
         <p:nvSpPr>
-          <p:cNvPr id="9" name="text-112"/>
+          <p:cNvPr id="9" name="text-127"/>
           <p:cNvSpPr txBox="1"/>
           <p:nvPr/>
         </p:nvSpPr>
@@ -17133,7 +17570,7 @@
       </p:sp>
       <p:sp>
         <p:nvSpPr>
-          <p:cNvPr id="10" name="text-113"/>
+          <p:cNvPr id="10" name="text-128"/>
           <p:cNvSpPr txBox="1"/>
           <p:nvPr/>
         </p:nvSpPr>
@@ -17169,7 +17606,7 @@
       </p:sp>
       <p:graphicFrame>
         <p:nvGraphicFramePr>
-          <p:cNvPr id="11" name="jb-chart-114" descr=""/>
+          <p:cNvPr id="11" name="jb-chart-129" descr=""/>
           <p:cNvGraphicFramePr/>
           <p:nvPr/>
         </p:nvGraphicFramePr>
@@ -17293,7 +17730,7 @@
       </p:sp>
       <p:sp>
         <p:nvSpPr>
-          <p:cNvPr id="3" name="card-115"/>
+          <p:cNvPr id="3" name="card-130"/>
           <p:cNvSpPr/>
           <p:nvPr/>
         </p:nvSpPr>
@@ -17315,7 +17752,7 @@
       </p:sp>
       <p:sp>
         <p:nvSpPr>
-          <p:cNvPr id="4" name="badge-116"/>
+          <p:cNvPr id="4" name="badge-131"/>
           <p:cNvSpPr/>
           <p:nvPr/>
         </p:nvSpPr>
@@ -17335,7 +17772,7 @@
       </p:sp>
       <p:sp>
         <p:nvSpPr>
-          <p:cNvPr id="5" name="badge-text-117"/>
+          <p:cNvPr id="5" name="badge-text-132"/>
           <p:cNvSpPr txBox="1"/>
           <p:nvPr/>
         </p:nvSpPr>
@@ -17371,7 +17808,7 @@
       </p:sp>
       <p:sp>
         <p:nvSpPr>
-          <p:cNvPr id="6" name="text-118"/>
+          <p:cNvPr id="6" name="text-133"/>
           <p:cNvSpPr txBox="1"/>
           <p:nvPr/>
         </p:nvSpPr>
@@ -17407,7 +17844,7 @@
       </p:sp>
       <p:sp>
         <p:nvSpPr>
-          <p:cNvPr id="7" name="text-119"/>
+          <p:cNvPr id="7" name="text-134"/>
           <p:cNvSpPr txBox="1"/>
           <p:nvPr/>
         </p:nvSpPr>
@@ -17443,7 +17880,7 @@
       </p:sp>
       <p:sp>
         <p:nvSpPr>
-          <p:cNvPr id="8" name="card-120"/>
+          <p:cNvPr id="8" name="card-135"/>
           <p:cNvSpPr/>
           <p:nvPr/>
         </p:nvSpPr>
@@ -17465,7 +17902,7 @@
       </p:sp>
       <p:sp>
         <p:nvSpPr>
-          <p:cNvPr id="9" name="badge-121"/>
+          <p:cNvPr id="9" name="badge-136"/>
           <p:cNvSpPr/>
           <p:nvPr/>
         </p:nvSpPr>
@@ -17485,7 +17922,7 @@
       </p:sp>
       <p:sp>
         <p:nvSpPr>
-          <p:cNvPr id="10" name="badge-text-122"/>
+          <p:cNvPr id="10" name="badge-text-137"/>
           <p:cNvSpPr txBox="1"/>
           <p:nvPr/>
         </p:nvSpPr>
@@ -17521,7 +17958,7 @@
       </p:sp>
       <p:sp>
         <p:nvSpPr>
-          <p:cNvPr id="11" name="text-123"/>
+          <p:cNvPr id="11" name="text-138"/>
           <p:cNvSpPr txBox="1"/>
           <p:nvPr/>
         </p:nvSpPr>
@@ -17557,7 +17994,7 @@
       </p:sp>
       <p:sp>
         <p:nvSpPr>
-          <p:cNvPr id="12" name="text-124"/>
+          <p:cNvPr id="12" name="text-139"/>
           <p:cNvSpPr txBox="1"/>
           <p:nvPr/>
         </p:nvSpPr>
@@ -17593,7 +18030,7 @@
       </p:sp>
       <p:sp>
         <p:nvSpPr>
-          <p:cNvPr id="13" name="card-125"/>
+          <p:cNvPr id="13" name="card-140"/>
           <p:cNvSpPr/>
           <p:nvPr/>
         </p:nvSpPr>
@@ -17615,7 +18052,7 @@
       </p:sp>
       <p:sp>
         <p:nvSpPr>
-          <p:cNvPr id="14" name="badge-126"/>
+          <p:cNvPr id="14" name="badge-141"/>
           <p:cNvSpPr/>
           <p:nvPr/>
         </p:nvSpPr>
@@ -17635,7 +18072,7 @@
       </p:sp>
       <p:sp>
         <p:nvSpPr>
-          <p:cNvPr id="15" name="badge-text-127"/>
+          <p:cNvPr id="15" name="badge-text-142"/>
           <p:cNvSpPr txBox="1"/>
           <p:nvPr/>
         </p:nvSpPr>
@@ -17671,7 +18108,7 @@
       </p:sp>
       <p:sp>
         <p:nvSpPr>
-          <p:cNvPr id="16" name="text-128"/>
+          <p:cNvPr id="16" name="text-143"/>
           <p:cNvSpPr txBox="1"/>
           <p:nvPr/>
         </p:nvSpPr>
@@ -17707,7 +18144,7 @@
       </p:sp>
       <p:sp>
         <p:nvSpPr>
-          <p:cNvPr id="17" name="text-129"/>
+          <p:cNvPr id="17" name="text-144"/>
           <p:cNvSpPr txBox="1"/>
           <p:nvPr/>
         </p:nvSpPr>
@@ -17743,7 +18180,7 @@
       </p:sp>
       <p:sp>
         <p:nvSpPr>
-          <p:cNvPr id="18" name="card-130"/>
+          <p:cNvPr id="18" name="card-145"/>
           <p:cNvSpPr/>
           <p:nvPr/>
         </p:nvSpPr>
@@ -17765,7 +18202,7 @@
       </p:sp>
       <p:sp>
         <p:nvSpPr>
-          <p:cNvPr id="19" name="badge-131"/>
+          <p:cNvPr id="19" name="badge-146"/>
           <p:cNvSpPr/>
           <p:nvPr/>
         </p:nvSpPr>
@@ -17785,7 +18222,7 @@
       </p:sp>
       <p:sp>
         <p:nvSpPr>
-          <p:cNvPr id="20" name="badge-text-132"/>
+          <p:cNvPr id="20" name="badge-text-147"/>
           <p:cNvSpPr txBox="1"/>
           <p:nvPr/>
         </p:nvSpPr>
@@ -17821,7 +18258,7 @@
       </p:sp>
       <p:sp>
         <p:nvSpPr>
-          <p:cNvPr id="21" name="text-133"/>
+          <p:cNvPr id="21" name="text-148"/>
           <p:cNvSpPr txBox="1"/>
           <p:nvPr/>
         </p:nvSpPr>
@@ -17857,7 +18294,7 @@
       </p:sp>
       <p:sp>
         <p:nvSpPr>
-          <p:cNvPr id="22" name="text-134"/>
+          <p:cNvPr id="22" name="text-149"/>
           <p:cNvSpPr txBox="1"/>
           <p:nvPr/>
         </p:nvSpPr>
@@ -17893,7 +18330,7 @@
       </p:sp>
       <p:sp>
         <p:nvSpPr>
-          <p:cNvPr id="23" name="text-135"/>
+          <p:cNvPr id="23" name="text-150"/>
           <p:cNvSpPr txBox="1"/>
           <p:nvPr/>
         </p:nvSpPr>
@@ -17932,7 +18369,7 @@
       </p:sp>
       <p:sp>
         <p:nvSpPr>
-          <p:cNvPr id="24" name="text-136"/>
+          <p:cNvPr id="24" name="text-151"/>
           <p:cNvSpPr txBox="1"/>
           <p:nvPr/>
         </p:nvSpPr>
@@ -17968,7 +18405,7 @@
       </p:sp>
       <p:sp>
         <p:nvSpPr>
-          <p:cNvPr id="25" name="text-137"/>
+          <p:cNvPr id="25" name="text-152"/>
           <p:cNvSpPr txBox="1"/>
           <p:nvPr/>
         </p:nvSpPr>
@@ -18007,7 +18444,7 @@
       </p:sp>
       <p:sp>
         <p:nvSpPr>
-          <p:cNvPr id="26" name="text-138"/>
+          <p:cNvPr id="26" name="text-153"/>
           <p:cNvSpPr txBox="1"/>
           <p:nvPr/>
         </p:nvSpPr>
@@ -18151,7 +18588,7 @@
       </p:sp>
       <p:graphicFrame>
         <p:nvGraphicFramePr>
-          <p:cNvPr id="3" name="ladder-139" descr=""/>
+          <p:cNvPr id="3" name="ladder-154" descr=""/>
           <p:cNvGraphicFramePr/>
           <p:nvPr/>
         </p:nvGraphicFramePr>
@@ -18167,7 +18604,7 @@
       </p:graphicFrame>
       <p:sp>
         <p:nvSpPr>
-          <p:cNvPr id="4" name="badge-140"/>
+          <p:cNvPr id="4" name="badge-155"/>
           <p:cNvSpPr/>
           <p:nvPr/>
         </p:nvSpPr>
@@ -18187,7 +18624,7 @@
       </p:sp>
       <p:sp>
         <p:nvSpPr>
-          <p:cNvPr id="5" name="badge-text-141"/>
+          <p:cNvPr id="5" name="badge-text-156"/>
           <p:cNvSpPr txBox="1"/>
           <p:nvPr/>
         </p:nvSpPr>
@@ -18223,7 +18660,7 @@
       </p:sp>
       <p:sp>
         <p:nvSpPr>
-          <p:cNvPr id="6" name="text-142"/>
+          <p:cNvPr id="6" name="text-157"/>
           <p:cNvSpPr txBox="1"/>
           <p:nvPr/>
         </p:nvSpPr>
@@ -18259,7 +18696,7 @@
       </p:sp>
       <p:sp>
         <p:nvSpPr>
-          <p:cNvPr id="7" name="badge-143"/>
+          <p:cNvPr id="7" name="badge-158"/>
           <p:cNvSpPr/>
           <p:nvPr/>
         </p:nvSpPr>
@@ -18279,7 +18716,7 @@
       </p:sp>
       <p:sp>
         <p:nvSpPr>
-          <p:cNvPr id="8" name="badge-text-144"/>
+          <p:cNvPr id="8" name="badge-text-159"/>
           <p:cNvSpPr txBox="1"/>
           <p:nvPr/>
         </p:nvSpPr>
@@ -18315,7 +18752,7 @@
       </p:sp>
       <p:sp>
         <p:nvSpPr>
-          <p:cNvPr id="9" name="text-145"/>
+          <p:cNvPr id="9" name="text-160"/>
           <p:cNvSpPr txBox="1"/>
           <p:nvPr/>
         </p:nvSpPr>
@@ -18351,7 +18788,7 @@
       </p:sp>
       <p:sp>
         <p:nvSpPr>
-          <p:cNvPr id="10" name="badge-146"/>
+          <p:cNvPr id="10" name="badge-161"/>
           <p:cNvSpPr/>
           <p:nvPr/>
         </p:nvSpPr>
@@ -18371,7 +18808,7 @@
       </p:sp>
       <p:sp>
         <p:nvSpPr>
-          <p:cNvPr id="11" name="badge-text-147"/>
+          <p:cNvPr id="11" name="badge-text-162"/>
           <p:cNvSpPr txBox="1"/>
           <p:nvPr/>
         </p:nvSpPr>
@@ -18407,7 +18844,7 @@
       </p:sp>
       <p:sp>
         <p:nvSpPr>
-          <p:cNvPr id="12" name="text-148"/>
+          <p:cNvPr id="12" name="text-163"/>
           <p:cNvSpPr txBox="1"/>
           <p:nvPr/>
         </p:nvSpPr>
@@ -18443,7 +18880,7 @@
       </p:sp>
       <p:sp>
         <p:nvSpPr>
-          <p:cNvPr id="13" name="badge-149"/>
+          <p:cNvPr id="13" name="badge-164"/>
           <p:cNvSpPr/>
           <p:nvPr/>
         </p:nvSpPr>
@@ -18463,7 +18900,7 @@
       </p:sp>
       <p:sp>
         <p:nvSpPr>
-          <p:cNvPr id="14" name="badge-text-150"/>
+          <p:cNvPr id="14" name="badge-text-165"/>
           <p:cNvSpPr txBox="1"/>
           <p:nvPr/>
         </p:nvSpPr>
@@ -18499,7 +18936,7 @@
       </p:sp>
       <p:sp>
         <p:nvSpPr>
-          <p:cNvPr id="15" name="text-151"/>
+          <p:cNvPr id="15" name="text-166"/>
           <p:cNvSpPr txBox="1"/>
           <p:nvPr/>
         </p:nvSpPr>

</xml_diff>